<commit_message>
docs: update skill references and workflows to include new skills for OpenFeign and unit/integration testing
</commit_message>
<xml_diff>
--- a/presentations/presentacion-ejecutiva-skills-ia-bcv-v2.pptx
+++ b/presentations/presentacion-ejecutiva-skills-ia-bcv-v2.pptx
@@ -22591,12 +22591,12 @@
         </p:nvSpPr>
         <p:spPr>
           <a:xfrm>
-            <a:off x="365760" y="1600200"/>
-            <a:ext cx="887984" cy="1042416"/>
+            <a:off x="365760" y="1627632"/>
+            <a:ext cx="887984" cy="384048"/>
           </a:xfrm>
           <a:prstGeom prst="roundRect">
             <a:avLst>
-              <a:gd name="adj" fmla="val 9268"/>
+              <a:gd name="adj" fmla="val 33333"/>
             </a:avLst>
           </a:prstGeom>
           <a:solidFill>
@@ -22618,8 +22618,8 @@
         </p:nvSpPr>
         <p:spPr>
           <a:xfrm>
-            <a:off x="411480" y="1645920"/>
-            <a:ext cx="796544" cy="950976"/>
+            <a:off x="365760" y="1627632"/>
+            <a:ext cx="887984" cy="384048"/>
           </a:xfrm>
           <a:prstGeom prst="rect">
             <a:avLst/>
@@ -22628,17 +22628,17 @@
           <a:ln/>
         </p:spPr>
         <p:txBody>
-          <a:bodyPr wrap="square" lIns="0" tIns="0" rIns="0" bIns="0" rtlCol="0" anchor="t"/>
+          <a:bodyPr wrap="square" lIns="0" tIns="0" rIns="0" bIns="0" rtlCol="0" anchor="ctr"/>
           <a:lstStyle/>
           <a:p>
-            <a:pPr algn="l" indent="0" marL="0">
+            <a:pPr algn="ctr" indent="0" marL="0">
               <a:lnSpc>
-                <a:spcPct val="105000"/>
+                <a:spcPct val="100000"/>
               </a:lnSpc>
               <a:buNone/>
             </a:pPr>
             <a:r>
-              <a:rPr lang="en-US" sz="950" b="1" dirty="0">
+              <a:rPr lang="en-US" sz="1000" b="1" dirty="0">
                 <a:solidFill>
                   <a:srgbClr val="070F26"/>
                 </a:solidFill>
@@ -22649,9 +22649,9 @@
               <a:t>SEM 1
 </a:t>
             </a:r>
-            <a:pPr algn="l" indent="0" marL="0">
+            <a:pPr algn="ctr" indent="0" marL="0">
               <a:lnSpc>
-                <a:spcPct val="105000"/>
+                <a:spcPct val="100000"/>
               </a:lnSpc>
               <a:buNone/>
             </a:pPr>
@@ -22664,19 +22664,70 @@
                 <a:ea typeface="Arial" pitchFamily="34" charset="-122"/>
                 <a:cs typeface="Arial" pitchFamily="34" charset="-120"/>
               </a:rPr>
-              <a:t>13–19 ago
-</a:t>
+              <a:t>13–19 ago</a:t>
             </a:r>
+            <a:endParaRPr lang="en-US" sz="1000" dirty="0"/>
+          </a:p>
+        </p:txBody>
+      </p:sp>
+      <p:sp>
+        <p:nvSpPr>
+          <p:cNvPr id="16" name="Shape 13"/>
+          <p:cNvSpPr/>
+          <p:nvPr/>
+        </p:nvSpPr>
+        <p:spPr>
+          <a:xfrm>
+            <a:off x="365760" y="2103120"/>
+            <a:ext cx="887984" cy="1280160"/>
+          </a:xfrm>
+          <a:prstGeom prst="roundRect">
+            <a:avLst>
+              <a:gd name="adj" fmla="val 8238"/>
+            </a:avLst>
+          </a:prstGeom>
+          <a:solidFill>
+            <a:srgbClr val="0A1A2E"/>
+          </a:solidFill>
+          <a:ln w="15875">
+            <a:solidFill>
+              <a:srgbClr val="00CB5D"/>
+            </a:solidFill>
+            <a:prstDash val="solid"/>
+          </a:ln>
+        </p:spPr>
+      </p:sp>
+      <p:sp>
+        <p:nvSpPr>
+          <p:cNvPr id="17" name="Text 14"/>
+          <p:cNvSpPr/>
+          <p:nvPr/>
+        </p:nvSpPr>
+        <p:spPr>
+          <a:xfrm>
+            <a:off x="420624" y="2157984"/>
+            <a:ext cx="778256" cy="1170432"/>
+          </a:xfrm>
+          <a:prstGeom prst="rect">
+            <a:avLst/>
+          </a:prstGeom>
+          <a:noFill/>
+          <a:ln/>
+        </p:spPr>
+        <p:txBody>
+          <a:bodyPr wrap="square" lIns="0" tIns="0" rIns="0" bIns="0" rtlCol="0" anchor="ctr"/>
+          <a:lstStyle/>
+          <a:p>
             <a:pPr algn="l" indent="0" marL="0">
               <a:lnSpc>
-                <a:spcPct val="105000"/>
+                <a:spcPct val="108000"/>
               </a:lnSpc>
               <a:buNone/>
             </a:pPr>
             <a:r>
-              <a:rPr lang="en-US" sz="700" dirty="0">
+              <a:rPr lang="en-US" sz="850" dirty="0">
                 <a:solidFill>
-                  <a:srgbClr val="070F26"/>
+                  <a:srgbClr val="FFFFFF"/>
                 </a:solidFill>
                 <a:latin typeface="Arial" pitchFamily="34" charset="0"/>
                 <a:ea typeface="Arial" pitchFamily="34" charset="-122"/>
@@ -22684,24 +22735,93 @@
               </a:rPr>
               <a:t>Consolidación de repos + entorno</a:t>
             </a:r>
-            <a:endParaRPr lang="en-US" sz="950" dirty="0"/>
+            <a:endParaRPr lang="en-US" sz="850" dirty="0"/>
           </a:p>
         </p:txBody>
       </p:sp>
       <p:sp>
         <p:nvSpPr>
-          <p:cNvPr id="16" name="Shape 13"/>
-          <p:cNvSpPr/>
-          <p:nvPr/>
-        </p:nvSpPr>
-        <p:spPr>
-          <a:xfrm>
-            <a:off x="1317752" y="1600200"/>
-            <a:ext cx="887984" cy="1042416"/>
+          <p:cNvPr id="18" name="Shape 15"/>
+          <p:cNvSpPr/>
+          <p:nvPr/>
+        </p:nvSpPr>
+        <p:spPr>
+          <a:xfrm>
+            <a:off x="365760" y="3474720"/>
+            <a:ext cx="887984" cy="1280160"/>
           </a:xfrm>
           <a:prstGeom prst="roundRect">
             <a:avLst>
-              <a:gd name="adj" fmla="val 9268"/>
+              <a:gd name="adj" fmla="val 8238"/>
+            </a:avLst>
+          </a:prstGeom>
+          <a:solidFill>
+            <a:srgbClr val="0A1A2E"/>
+          </a:solidFill>
+          <a:ln w="15875">
+            <a:solidFill>
+              <a:srgbClr val="00CB5D"/>
+            </a:solidFill>
+            <a:prstDash val="solid"/>
+          </a:ln>
+        </p:spPr>
+      </p:sp>
+      <p:sp>
+        <p:nvSpPr>
+          <p:cNvPr id="19" name="Text 16"/>
+          <p:cNvSpPr/>
+          <p:nvPr/>
+        </p:nvSpPr>
+        <p:spPr>
+          <a:xfrm>
+            <a:off x="420624" y="3529584"/>
+            <a:ext cx="778256" cy="1170432"/>
+          </a:xfrm>
+          <a:prstGeom prst="rect">
+            <a:avLst/>
+          </a:prstGeom>
+          <a:noFill/>
+          <a:ln/>
+        </p:spPr>
+        <p:txBody>
+          <a:bodyPr wrap="square" lIns="0" tIns="0" rIns="0" bIns="0" rtlCol="0" anchor="ctr"/>
+          <a:lstStyle/>
+          <a:p>
+            <a:pPr algn="l" indent="0" marL="0">
+              <a:lnSpc>
+                <a:spcPct val="108000"/>
+              </a:lnSpc>
+              <a:buNone/>
+            </a:pPr>
+            <a:r>
+              <a:rPr lang="en-US" sz="850" dirty="0">
+                <a:solidFill>
+                  <a:srgbClr val="FFFFFF"/>
+                </a:solidFill>
+                <a:latin typeface="Arial" pitchFamily="34" charset="0"/>
+                <a:ea typeface="Arial" pitchFamily="34" charset="-122"/>
+                <a:cs typeface="Arial" pitchFamily="34" charset="-120"/>
+              </a:rPr>
+              <a:t>Arranque skills del pipeline (context-analyzer, dhu-writer, implementer)</a:t>
+            </a:r>
+            <a:endParaRPr lang="en-US" sz="850" dirty="0"/>
+          </a:p>
+        </p:txBody>
+      </p:sp>
+      <p:sp>
+        <p:nvSpPr>
+          <p:cNvPr id="20" name="Shape 17"/>
+          <p:cNvSpPr/>
+          <p:nvPr/>
+        </p:nvSpPr>
+        <p:spPr>
+          <a:xfrm>
+            <a:off x="1317752" y="1627632"/>
+            <a:ext cx="887984" cy="384048"/>
+          </a:xfrm>
+          <a:prstGeom prst="roundRect">
+            <a:avLst>
+              <a:gd name="adj" fmla="val 33333"/>
             </a:avLst>
           </a:prstGeom>
           <a:solidFill>
@@ -22717,14 +22837,14 @@
       </p:sp>
       <p:sp>
         <p:nvSpPr>
-          <p:cNvPr id="17" name="Text 14"/>
-          <p:cNvSpPr/>
-          <p:nvPr/>
-        </p:nvSpPr>
-        <p:spPr>
-          <a:xfrm>
-            <a:off x="1363472" y="1645920"/>
-            <a:ext cx="796544" cy="950976"/>
+          <p:cNvPr id="21" name="Text 18"/>
+          <p:cNvSpPr/>
+          <p:nvPr/>
+        </p:nvSpPr>
+        <p:spPr>
+          <a:xfrm>
+            <a:off x="1317752" y="1627632"/>
+            <a:ext cx="887984" cy="384048"/>
           </a:xfrm>
           <a:prstGeom prst="rect">
             <a:avLst/>
@@ -22733,17 +22853,17 @@
           <a:ln/>
         </p:spPr>
         <p:txBody>
-          <a:bodyPr wrap="square" lIns="0" tIns="0" rIns="0" bIns="0" rtlCol="0" anchor="t"/>
+          <a:bodyPr wrap="square" lIns="0" tIns="0" rIns="0" bIns="0" rtlCol="0" anchor="ctr"/>
           <a:lstStyle/>
           <a:p>
-            <a:pPr algn="l" indent="0" marL="0">
+            <a:pPr algn="ctr" indent="0" marL="0">
               <a:lnSpc>
-                <a:spcPct val="105000"/>
+                <a:spcPct val="100000"/>
               </a:lnSpc>
               <a:buNone/>
             </a:pPr>
             <a:r>
-              <a:rPr lang="en-US" sz="950" b="1" dirty="0">
+              <a:rPr lang="en-US" sz="1000" b="1" dirty="0">
                 <a:solidFill>
                   <a:srgbClr val="070F26"/>
                 </a:solidFill>
@@ -22754,9 +22874,9 @@
               <a:t>SEM 2
 </a:t>
             </a:r>
-            <a:pPr algn="l" indent="0" marL="0">
+            <a:pPr algn="ctr" indent="0" marL="0">
               <a:lnSpc>
-                <a:spcPct val="105000"/>
+                <a:spcPct val="100000"/>
               </a:lnSpc>
               <a:buNone/>
             </a:pPr>
@@ -22769,33 +22889,153 @@
                 <a:ea typeface="Arial" pitchFamily="34" charset="-122"/>
                 <a:cs typeface="Arial" pitchFamily="34" charset="-120"/>
               </a:rPr>
-              <a:t>20–26 ago
-</a:t>
+              <a:t>20–26 ago</a:t>
             </a:r>
+            <a:endParaRPr lang="en-US" sz="1000" dirty="0"/>
+          </a:p>
+        </p:txBody>
+      </p:sp>
+      <p:sp>
+        <p:nvSpPr>
+          <p:cNvPr id="22" name="Shape 19"/>
+          <p:cNvSpPr/>
+          <p:nvPr/>
+        </p:nvSpPr>
+        <p:spPr>
+          <a:xfrm>
+            <a:off x="1317752" y="2103120"/>
+            <a:ext cx="887984" cy="1280160"/>
+          </a:xfrm>
+          <a:prstGeom prst="roundRect">
+            <a:avLst>
+              <a:gd name="adj" fmla="val 8238"/>
+            </a:avLst>
+          </a:prstGeom>
+          <a:solidFill>
+            <a:srgbClr val="0A1A2E"/>
+          </a:solidFill>
+          <a:ln w="15875">
+            <a:solidFill>
+              <a:srgbClr val="00CB5D"/>
+            </a:solidFill>
+            <a:prstDash val="solid"/>
+          </a:ln>
+        </p:spPr>
+      </p:sp>
+      <p:sp>
+        <p:nvSpPr>
+          <p:cNvPr id="23" name="Text 20"/>
+          <p:cNvSpPr/>
+          <p:nvPr/>
+        </p:nvSpPr>
+        <p:spPr>
+          <a:xfrm>
+            <a:off x="1372616" y="2157984"/>
+            <a:ext cx="778256" cy="1170432"/>
+          </a:xfrm>
+          <a:prstGeom prst="rect">
+            <a:avLst/>
+          </a:prstGeom>
+          <a:noFill/>
+          <a:ln/>
+        </p:spPr>
+        <p:txBody>
+          <a:bodyPr wrap="square" lIns="0" tIns="0" rIns="0" bIns="0" rtlCol="0" anchor="ctr"/>
+          <a:lstStyle/>
+          <a:p>
             <a:pPr algn="l" indent="0" marL="0">
               <a:lnSpc>
-                <a:spcPct val="105000"/>
+                <a:spcPct val="108000"/>
               </a:lnSpc>
               <a:buNone/>
             </a:pPr>
             <a:r>
-              <a:rPr lang="en-US" sz="700" dirty="0">
+              <a:rPr lang="en-US" sz="850" dirty="0">
                 <a:solidFill>
-                  <a:srgbClr val="070F26"/>
+                  <a:srgbClr val="FFFFFF"/>
                 </a:solidFill>
                 <a:latin typeface="Arial" pitchFamily="34" charset="0"/>
                 <a:ea typeface="Arial" pitchFamily="34" charset="-122"/>
                 <a:cs typeface="Arial" pitchFamily="34" charset="-120"/>
               </a:rPr>
-              <a:t>Sprint 1 · pipeline + 1er ejercicio (Fernando)</a:t>
+              <a:t>Adopción de graphify + creación bcv-hexagonal-architecture y bcv-java-spring-boot</a:t>
             </a:r>
-            <a:endParaRPr lang="en-US" sz="950" dirty="0"/>
+            <a:endParaRPr lang="en-US" sz="850" dirty="0"/>
           </a:p>
         </p:txBody>
       </p:sp>
       <p:sp>
         <p:nvSpPr>
-          <p:cNvPr id="18" name="Shape 15"/>
+          <p:cNvPr id="24" name="Shape 21"/>
+          <p:cNvSpPr/>
+          <p:nvPr/>
+        </p:nvSpPr>
+        <p:spPr>
+          <a:xfrm>
+            <a:off x="1317752" y="3474720"/>
+            <a:ext cx="887984" cy="1280160"/>
+          </a:xfrm>
+          <a:prstGeom prst="roundRect">
+            <a:avLst>
+              <a:gd name="adj" fmla="val 8238"/>
+            </a:avLst>
+          </a:prstGeom>
+          <a:solidFill>
+            <a:srgbClr val="0A1A2E"/>
+          </a:solidFill>
+          <a:ln w="15875">
+            <a:solidFill>
+              <a:srgbClr val="00CB5D"/>
+            </a:solidFill>
+            <a:prstDash val="solid"/>
+          </a:ln>
+        </p:spPr>
+      </p:sp>
+      <p:sp>
+        <p:nvSpPr>
+          <p:cNvPr id="25" name="Text 22"/>
+          <p:cNvSpPr/>
+          <p:nvPr/>
+        </p:nvSpPr>
+        <p:spPr>
+          <a:xfrm>
+            <a:off x="1372616" y="3529584"/>
+            <a:ext cx="778256" cy="1170432"/>
+          </a:xfrm>
+          <a:prstGeom prst="rect">
+            <a:avLst/>
+          </a:prstGeom>
+          <a:noFill/>
+          <a:ln/>
+        </p:spPr>
+        <p:txBody>
+          <a:bodyPr wrap="square" lIns="0" tIns="0" rIns="0" bIns="0" rtlCol="0" anchor="ctr"/>
+          <a:lstStyle/>
+          <a:p>
+            <a:pPr algn="l" indent="0" marL="0">
+              <a:lnSpc>
+                <a:spcPct val="108000"/>
+              </a:lnSpc>
+              <a:buNone/>
+            </a:pPr>
+            <a:r>
+              <a:rPr lang="en-US" sz="850" dirty="0">
+                <a:solidFill>
+                  <a:srgbClr val="FFFFFF"/>
+                </a:solidFill>
+                <a:latin typeface="Arial" pitchFamily="34" charset="0"/>
+                <a:ea typeface="Arial" pitchFamily="34" charset="-122"/>
+                <a:cs typeface="Arial" pitchFamily="34" charset="-120"/>
+              </a:rPr>
+              <a:t>Ejecución de HU con equipo dev (primer ejercicio real)</a:t>
+            </a:r>
+            <a:endParaRPr lang="en-US" sz="850" dirty="0"/>
+          </a:p>
+        </p:txBody>
+      </p:sp>
+      <p:sp>
+        <p:nvSpPr>
+          <p:cNvPr id="26" name="Shape 23"/>
           <p:cNvSpPr/>
           <p:nvPr/>
         </p:nvSpPr>
@@ -22822,7 +23062,7 @@
       </p:sp>
       <p:sp>
         <p:nvSpPr>
-          <p:cNvPr id="19" name="Text 16"/>
+          <p:cNvPr id="27" name="Text 24"/>
           <p:cNvSpPr/>
           <p:nvPr/>
         </p:nvSpPr>
@@ -22861,7 +23101,7 @@
       </p:sp>
       <p:sp>
         <p:nvSpPr>
-          <p:cNvPr id="20" name="Text 17"/>
+          <p:cNvPr id="28" name="Text 25"/>
           <p:cNvSpPr/>
           <p:nvPr/>
         </p:nvSpPr>
@@ -22900,18 +23140,18 @@
       </p:sp>
       <p:sp>
         <p:nvSpPr>
-          <p:cNvPr id="21" name="Shape 18"/>
-          <p:cNvSpPr/>
-          <p:nvPr/>
-        </p:nvSpPr>
-        <p:spPr>
-          <a:xfrm>
-            <a:off x="2269744" y="1600200"/>
-            <a:ext cx="887984" cy="1042416"/>
+          <p:cNvPr id="29" name="Shape 26"/>
+          <p:cNvSpPr/>
+          <p:nvPr/>
+        </p:nvSpPr>
+        <p:spPr>
+          <a:xfrm>
+            <a:off x="2269744" y="1627632"/>
+            <a:ext cx="887984" cy="384048"/>
           </a:xfrm>
           <a:prstGeom prst="roundRect">
             <a:avLst>
-              <a:gd name="adj" fmla="val 9268"/>
+              <a:gd name="adj" fmla="val 33333"/>
             </a:avLst>
           </a:prstGeom>
           <a:solidFill>
@@ -22927,14 +23167,14 @@
       </p:sp>
       <p:sp>
         <p:nvSpPr>
-          <p:cNvPr id="22" name="Text 19"/>
-          <p:cNvSpPr/>
-          <p:nvPr/>
-        </p:nvSpPr>
-        <p:spPr>
-          <a:xfrm>
-            <a:off x="2315464" y="1645920"/>
-            <a:ext cx="796544" cy="950976"/>
+          <p:cNvPr id="30" name="Text 27"/>
+          <p:cNvSpPr/>
+          <p:nvPr/>
+        </p:nvSpPr>
+        <p:spPr>
+          <a:xfrm>
+            <a:off x="2269744" y="1627632"/>
+            <a:ext cx="887984" cy="384048"/>
           </a:xfrm>
           <a:prstGeom prst="rect">
             <a:avLst/>
@@ -22943,17 +23183,17 @@
           <a:ln/>
         </p:spPr>
         <p:txBody>
-          <a:bodyPr wrap="square" lIns="0" tIns="0" rIns="0" bIns="0" rtlCol="0" anchor="t"/>
+          <a:bodyPr wrap="square" lIns="0" tIns="0" rIns="0" bIns="0" rtlCol="0" anchor="ctr"/>
           <a:lstStyle/>
           <a:p>
-            <a:pPr algn="l" indent="0" marL="0">
+            <a:pPr algn="ctr" indent="0" marL="0">
               <a:lnSpc>
-                <a:spcPct val="105000"/>
+                <a:spcPct val="100000"/>
               </a:lnSpc>
               <a:buNone/>
             </a:pPr>
             <a:r>
-              <a:rPr lang="en-US" sz="950" b="1" dirty="0">
+              <a:rPr lang="en-US" sz="1000" b="1" dirty="0">
                 <a:solidFill>
                   <a:srgbClr val="070F26"/>
                 </a:solidFill>
@@ -22964,9 +23204,9 @@
               <a:t>SEM 3
 </a:t>
             </a:r>
-            <a:pPr algn="l" indent="0" marL="0">
+            <a:pPr algn="ctr" indent="0" marL="0">
               <a:lnSpc>
-                <a:spcPct val="105000"/>
+                <a:spcPct val="100000"/>
               </a:lnSpc>
               <a:buNone/>
             </a:pPr>
@@ -22979,44 +23219,164 @@
                 <a:ea typeface="Arial" pitchFamily="34" charset="-122"/>
                 <a:cs typeface="Arial" pitchFamily="34" charset="-120"/>
               </a:rPr>
-              <a:t>27 ago–02 sep
-</a:t>
+              <a:t>27 ago–02 sep</a:t>
             </a:r>
+            <a:endParaRPr lang="en-US" sz="1000" dirty="0"/>
+          </a:p>
+        </p:txBody>
+      </p:sp>
+      <p:sp>
+        <p:nvSpPr>
+          <p:cNvPr id="31" name="Shape 28"/>
+          <p:cNvSpPr/>
+          <p:nvPr/>
+        </p:nvSpPr>
+        <p:spPr>
+          <a:xfrm>
+            <a:off x="2269744" y="2103120"/>
+            <a:ext cx="887984" cy="1280160"/>
+          </a:xfrm>
+          <a:prstGeom prst="roundRect">
+            <a:avLst>
+              <a:gd name="adj" fmla="val 8238"/>
+            </a:avLst>
+          </a:prstGeom>
+          <a:solidFill>
+            <a:srgbClr val="0A1A2E"/>
+          </a:solidFill>
+          <a:ln w="15875">
+            <a:solidFill>
+              <a:srgbClr val="00CB5D"/>
+            </a:solidFill>
+            <a:prstDash val="solid"/>
+          </a:ln>
+        </p:spPr>
+      </p:sp>
+      <p:sp>
+        <p:nvSpPr>
+          <p:cNvPr id="32" name="Text 29"/>
+          <p:cNvSpPr/>
+          <p:nvPr/>
+        </p:nvSpPr>
+        <p:spPr>
+          <a:xfrm>
+            <a:off x="2324608" y="2157984"/>
+            <a:ext cx="778256" cy="1170432"/>
+          </a:xfrm>
+          <a:prstGeom prst="rect">
+            <a:avLst/>
+          </a:prstGeom>
+          <a:noFill/>
+          <a:ln/>
+        </p:spPr>
+        <p:txBody>
+          <a:bodyPr wrap="square" lIns="0" tIns="0" rIns="0" bIns="0" rtlCol="0" anchor="ctr"/>
+          <a:lstStyle/>
+          <a:p>
             <a:pPr algn="l" indent="0" marL="0">
               <a:lnSpc>
-                <a:spcPct val="105000"/>
+                <a:spcPct val="108000"/>
               </a:lnSpc>
               <a:buNone/>
             </a:pPr>
             <a:r>
-              <a:rPr lang="en-US" sz="700" dirty="0">
+              <a:rPr lang="en-US" sz="850" dirty="0">
                 <a:solidFill>
-                  <a:srgbClr val="070F26"/>
+                  <a:srgbClr val="FFFFFF"/>
                 </a:solidFill>
                 <a:latin typeface="Arial" pitchFamily="34" charset="0"/>
                 <a:ea typeface="Arial" pitchFamily="34" charset="-122"/>
                 <a:cs typeface="Arial" pitchFamily="34" charset="-120"/>
               </a:rPr>
-              <a:t>Sprint 2 · validación EVT (Lionel)</a:t>
+              <a:t>Creación bcv-clean-architecture, bcv-openapi-design y bcv-openfeign</a:t>
             </a:r>
-            <a:endParaRPr lang="en-US" sz="950" dirty="0"/>
+            <a:endParaRPr lang="en-US" sz="850" dirty="0"/>
           </a:p>
         </p:txBody>
       </p:sp>
       <p:sp>
         <p:nvSpPr>
-          <p:cNvPr id="23" name="Shape 20"/>
-          <p:cNvSpPr/>
-          <p:nvPr/>
-        </p:nvSpPr>
-        <p:spPr>
-          <a:xfrm>
-            <a:off x="3221736" y="1600200"/>
-            <a:ext cx="887984" cy="1042416"/>
+          <p:cNvPr id="33" name="Shape 30"/>
+          <p:cNvSpPr/>
+          <p:nvPr/>
+        </p:nvSpPr>
+        <p:spPr>
+          <a:xfrm>
+            <a:off x="2269744" y="3474720"/>
+            <a:ext cx="887984" cy="1280160"/>
           </a:xfrm>
           <a:prstGeom prst="roundRect">
             <a:avLst>
-              <a:gd name="adj" fmla="val 9268"/>
+              <a:gd name="adj" fmla="val 8238"/>
+            </a:avLst>
+          </a:prstGeom>
+          <a:solidFill>
+            <a:srgbClr val="0A1A2E"/>
+          </a:solidFill>
+          <a:ln w="15875">
+            <a:solidFill>
+              <a:srgbClr val="00CB5D"/>
+            </a:solidFill>
+            <a:prstDash val="solid"/>
+          </a:ln>
+        </p:spPr>
+      </p:sp>
+      <p:sp>
+        <p:nvSpPr>
+          <p:cNvPr id="34" name="Text 31"/>
+          <p:cNvSpPr/>
+          <p:nvPr/>
+        </p:nvSpPr>
+        <p:spPr>
+          <a:xfrm>
+            <a:off x="2324608" y="3529584"/>
+            <a:ext cx="778256" cy="1170432"/>
+          </a:xfrm>
+          <a:prstGeom prst="rect">
+            <a:avLst/>
+          </a:prstGeom>
+          <a:noFill/>
+          <a:ln/>
+        </p:spPr>
+        <p:txBody>
+          <a:bodyPr wrap="square" lIns="0" tIns="0" rIns="0" bIns="0" rtlCol="0" anchor="ctr"/>
+          <a:lstStyle/>
+          <a:p>
+            <a:pPr algn="l" indent="0" marL="0">
+              <a:lnSpc>
+                <a:spcPct val="108000"/>
+              </a:lnSpc>
+              <a:buNone/>
+            </a:pPr>
+            <a:r>
+              <a:rPr lang="en-US" sz="850" dirty="0">
+                <a:solidFill>
+                  <a:srgbClr val="FFFFFF"/>
+                </a:solidFill>
+                <a:latin typeface="Arial" pitchFamily="34" charset="0"/>
+                <a:ea typeface="Arial" pitchFamily="34" charset="-122"/>
+                <a:cs typeface="Arial" pitchFamily="34" charset="-120"/>
+              </a:rPr>
+              <a:t>Ejecución EVT con equipo dev (context-analyzer → DHU → código)</a:t>
+            </a:r>
+            <a:endParaRPr lang="en-US" sz="850" dirty="0"/>
+          </a:p>
+        </p:txBody>
+      </p:sp>
+      <p:sp>
+        <p:nvSpPr>
+          <p:cNvPr id="35" name="Shape 32"/>
+          <p:cNvSpPr/>
+          <p:nvPr/>
+        </p:nvSpPr>
+        <p:spPr>
+          <a:xfrm>
+            <a:off x="3221736" y="1627632"/>
+            <a:ext cx="887984" cy="384048"/>
+          </a:xfrm>
+          <a:prstGeom prst="roundRect">
+            <a:avLst>
+              <a:gd name="adj" fmla="val 33333"/>
             </a:avLst>
           </a:prstGeom>
           <a:solidFill>
@@ -23032,14 +23392,14 @@
       </p:sp>
       <p:sp>
         <p:nvSpPr>
-          <p:cNvPr id="24" name="Text 21"/>
-          <p:cNvSpPr/>
-          <p:nvPr/>
-        </p:nvSpPr>
-        <p:spPr>
-          <a:xfrm>
-            <a:off x="3267456" y="1645920"/>
-            <a:ext cx="796544" cy="950976"/>
+          <p:cNvPr id="36" name="Text 33"/>
+          <p:cNvSpPr/>
+          <p:nvPr/>
+        </p:nvSpPr>
+        <p:spPr>
+          <a:xfrm>
+            <a:off x="3221736" y="1627632"/>
+            <a:ext cx="887984" cy="384048"/>
           </a:xfrm>
           <a:prstGeom prst="rect">
             <a:avLst/>
@@ -23048,17 +23408,17 @@
           <a:ln/>
         </p:spPr>
         <p:txBody>
-          <a:bodyPr wrap="square" lIns="0" tIns="0" rIns="0" bIns="0" rtlCol="0" anchor="t"/>
+          <a:bodyPr wrap="square" lIns="0" tIns="0" rIns="0" bIns="0" rtlCol="0" anchor="ctr"/>
           <a:lstStyle/>
           <a:p>
-            <a:pPr algn="l" indent="0" marL="0">
+            <a:pPr algn="ctr" indent="0" marL="0">
               <a:lnSpc>
-                <a:spcPct val="105000"/>
+                <a:spcPct val="100000"/>
               </a:lnSpc>
               <a:buNone/>
             </a:pPr>
             <a:r>
-              <a:rPr lang="en-US" sz="950" b="1" dirty="0">
+              <a:rPr lang="en-US" sz="1000" b="1" dirty="0">
                 <a:solidFill>
                   <a:srgbClr val="070F26"/>
                 </a:solidFill>
@@ -23069,9 +23429,9 @@
               <a:t>SEM 4
 </a:t>
             </a:r>
-            <a:pPr algn="l" indent="0" marL="0">
+            <a:pPr algn="ctr" indent="0" marL="0">
               <a:lnSpc>
-                <a:spcPct val="105000"/>
+                <a:spcPct val="100000"/>
               </a:lnSpc>
               <a:buNone/>
             </a:pPr>
@@ -23084,33 +23444,153 @@
                 <a:ea typeface="Arial" pitchFamily="34" charset="-122"/>
                 <a:cs typeface="Arial" pitchFamily="34" charset="-120"/>
               </a:rPr>
-              <a:t>03–09 sep
-</a:t>
+              <a:t>03–09 sep</a:t>
             </a:r>
+            <a:endParaRPr lang="en-US" sz="1000" dirty="0"/>
+          </a:p>
+        </p:txBody>
+      </p:sp>
+      <p:sp>
+        <p:nvSpPr>
+          <p:cNvPr id="37" name="Shape 34"/>
+          <p:cNvSpPr/>
+          <p:nvPr/>
+        </p:nvSpPr>
+        <p:spPr>
+          <a:xfrm>
+            <a:off x="3221736" y="2103120"/>
+            <a:ext cx="887984" cy="1280160"/>
+          </a:xfrm>
+          <a:prstGeom prst="roundRect">
+            <a:avLst>
+              <a:gd name="adj" fmla="val 8238"/>
+            </a:avLst>
+          </a:prstGeom>
+          <a:solidFill>
+            <a:srgbClr val="0A1A2E"/>
+          </a:solidFill>
+          <a:ln w="15875">
+            <a:solidFill>
+              <a:srgbClr val="F9E795"/>
+            </a:solidFill>
+            <a:prstDash val="solid"/>
+          </a:ln>
+        </p:spPr>
+      </p:sp>
+      <p:sp>
+        <p:nvSpPr>
+          <p:cNvPr id="38" name="Text 35"/>
+          <p:cNvSpPr/>
+          <p:nvPr/>
+        </p:nvSpPr>
+        <p:spPr>
+          <a:xfrm>
+            <a:off x="3276600" y="2157984"/>
+            <a:ext cx="778256" cy="1170432"/>
+          </a:xfrm>
+          <a:prstGeom prst="rect">
+            <a:avLst/>
+          </a:prstGeom>
+          <a:noFill/>
+          <a:ln/>
+        </p:spPr>
+        <p:txBody>
+          <a:bodyPr wrap="square" lIns="0" tIns="0" rIns="0" bIns="0" rtlCol="0" anchor="ctr"/>
+          <a:lstStyle/>
+          <a:p>
             <a:pPr algn="l" indent="0" marL="0">
               <a:lnSpc>
-                <a:spcPct val="105000"/>
+                <a:spcPct val="108000"/>
               </a:lnSpc>
               <a:buNone/>
             </a:pPr>
             <a:r>
-              <a:rPr lang="en-US" sz="700" dirty="0">
+              <a:rPr lang="en-US" sz="850" dirty="0">
                 <a:solidFill>
-                  <a:srgbClr val="070F26"/>
+                  <a:srgbClr val="FFFFFF"/>
                 </a:solidFill>
                 <a:latin typeface="Arial" pitchFamily="34" charset="0"/>
                 <a:ea typeface="Arial" pitchFamily="34" charset="-122"/>
                 <a:cs typeface="Arial" pitchFamily="34" charset="-120"/>
               </a:rPr>
-              <a:t>Sprint 2 · consolidación + iteración</a:t>
+              <a:t>Creación bcv-azure-service-bus y bcv-spring-data-jpa-sql-server</a:t>
             </a:r>
-            <a:endParaRPr lang="en-US" sz="950" dirty="0"/>
+            <a:endParaRPr lang="en-US" sz="850" dirty="0"/>
           </a:p>
         </p:txBody>
       </p:sp>
       <p:sp>
         <p:nvSpPr>
-          <p:cNvPr id="25" name="Shape 22"/>
+          <p:cNvPr id="39" name="Shape 36"/>
+          <p:cNvSpPr/>
+          <p:nvPr/>
+        </p:nvSpPr>
+        <p:spPr>
+          <a:xfrm>
+            <a:off x="3221736" y="3474720"/>
+            <a:ext cx="887984" cy="1280160"/>
+          </a:xfrm>
+          <a:prstGeom prst="roundRect">
+            <a:avLst>
+              <a:gd name="adj" fmla="val 8238"/>
+            </a:avLst>
+          </a:prstGeom>
+          <a:solidFill>
+            <a:srgbClr val="0A1A2E"/>
+          </a:solidFill>
+          <a:ln w="15875">
+            <a:solidFill>
+              <a:srgbClr val="F9E795"/>
+            </a:solidFill>
+            <a:prstDash val="solid"/>
+          </a:ln>
+        </p:spPr>
+      </p:sp>
+      <p:sp>
+        <p:nvSpPr>
+          <p:cNvPr id="40" name="Text 37"/>
+          <p:cNvSpPr/>
+          <p:nvPr/>
+        </p:nvSpPr>
+        <p:spPr>
+          <a:xfrm>
+            <a:off x="3276600" y="3529584"/>
+            <a:ext cx="778256" cy="1170432"/>
+          </a:xfrm>
+          <a:prstGeom prst="rect">
+            <a:avLst/>
+          </a:prstGeom>
+          <a:noFill/>
+          <a:ln/>
+        </p:spPr>
+        <p:txBody>
+          <a:bodyPr wrap="square" lIns="0" tIns="0" rIns="0" bIns="0" rtlCol="0" anchor="ctr"/>
+          <a:lstStyle/>
+          <a:p>
+            <a:pPr algn="l" indent="0" marL="0">
+              <a:lnSpc>
+                <a:spcPct val="108000"/>
+              </a:lnSpc>
+              <a:buNone/>
+            </a:pPr>
+            <a:r>
+              <a:rPr lang="en-US" sz="850" dirty="0">
+                <a:solidFill>
+                  <a:srgbClr val="FFFFFF"/>
+                </a:solidFill>
+                <a:latin typeface="Arial" pitchFamily="34" charset="0"/>
+                <a:ea typeface="Arial" pitchFamily="34" charset="-122"/>
+                <a:cs typeface="Arial" pitchFamily="34" charset="-120"/>
+              </a:rPr>
+              <a:t>Consolidar feedback e iterar skills con código real</a:t>
+            </a:r>
+            <a:endParaRPr lang="en-US" sz="850" dirty="0"/>
+          </a:p>
+        </p:txBody>
+      </p:sp>
+      <p:sp>
+        <p:nvSpPr>
+          <p:cNvPr id="41" name="Shape 38"/>
           <p:cNvSpPr/>
           <p:nvPr/>
         </p:nvSpPr>
@@ -23137,7 +23617,7 @@
       </p:sp>
       <p:sp>
         <p:nvSpPr>
-          <p:cNvPr id="26" name="Text 23"/>
+          <p:cNvPr id="42" name="Text 39"/>
           <p:cNvSpPr/>
           <p:nvPr/>
         </p:nvSpPr>
@@ -23176,7 +23656,7 @@
       </p:sp>
       <p:sp>
         <p:nvSpPr>
-          <p:cNvPr id="27" name="Text 24"/>
+          <p:cNvPr id="43" name="Text 40"/>
           <p:cNvSpPr/>
           <p:nvPr/>
         </p:nvSpPr>
@@ -23215,18 +23695,18 @@
       </p:sp>
       <p:sp>
         <p:nvSpPr>
-          <p:cNvPr id="28" name="Shape 25"/>
-          <p:cNvSpPr/>
-          <p:nvPr/>
-        </p:nvSpPr>
-        <p:spPr>
-          <a:xfrm>
-            <a:off x="4173728" y="1600200"/>
-            <a:ext cx="887984" cy="1042416"/>
+          <p:cNvPr id="44" name="Shape 41"/>
+          <p:cNvSpPr/>
+          <p:nvPr/>
+        </p:nvSpPr>
+        <p:spPr>
+          <a:xfrm>
+            <a:off x="4173728" y="1627632"/>
+            <a:ext cx="887984" cy="384048"/>
           </a:xfrm>
           <a:prstGeom prst="roundRect">
             <a:avLst>
-              <a:gd name="adj" fmla="val 9268"/>
+              <a:gd name="adj" fmla="val 33333"/>
             </a:avLst>
           </a:prstGeom>
           <a:solidFill>
@@ -23242,14 +23722,14 @@
       </p:sp>
       <p:sp>
         <p:nvSpPr>
-          <p:cNvPr id="29" name="Text 26"/>
-          <p:cNvSpPr/>
-          <p:nvPr/>
-        </p:nvSpPr>
-        <p:spPr>
-          <a:xfrm>
-            <a:off x="4219448" y="1645920"/>
-            <a:ext cx="796544" cy="950976"/>
+          <p:cNvPr id="45" name="Text 42"/>
+          <p:cNvSpPr/>
+          <p:nvPr/>
+        </p:nvSpPr>
+        <p:spPr>
+          <a:xfrm>
+            <a:off x="4173728" y="1627632"/>
+            <a:ext cx="887984" cy="384048"/>
           </a:xfrm>
           <a:prstGeom prst="rect">
             <a:avLst/>
@@ -23258,17 +23738,17 @@
           <a:ln/>
         </p:spPr>
         <p:txBody>
-          <a:bodyPr wrap="square" lIns="0" tIns="0" rIns="0" bIns="0" rtlCol="0" anchor="t"/>
+          <a:bodyPr wrap="square" lIns="0" tIns="0" rIns="0" bIns="0" rtlCol="0" anchor="ctr"/>
           <a:lstStyle/>
           <a:p>
-            <a:pPr algn="l" indent="0" marL="0">
+            <a:pPr algn="ctr" indent="0" marL="0">
               <a:lnSpc>
-                <a:spcPct val="105000"/>
+                <a:spcPct val="100000"/>
               </a:lnSpc>
               <a:buNone/>
             </a:pPr>
             <a:r>
-              <a:rPr lang="en-US" sz="950" b="1" dirty="0">
+              <a:rPr lang="en-US" sz="1000" b="1" dirty="0">
                 <a:solidFill>
                   <a:srgbClr val="FFFFFF"/>
                 </a:solidFill>
@@ -23279,9 +23759,9 @@
               <a:t>SEM 5
 </a:t>
             </a:r>
-            <a:pPr algn="l" indent="0" marL="0">
+            <a:pPr algn="ctr" indent="0" marL="0">
               <a:lnSpc>
-                <a:spcPct val="105000"/>
+                <a:spcPct val="100000"/>
               </a:lnSpc>
               <a:buNone/>
             </a:pPr>
@@ -23294,17 +23774,68 @@
                 <a:ea typeface="Arial" pitchFamily="34" charset="-122"/>
                 <a:cs typeface="Arial" pitchFamily="34" charset="-120"/>
               </a:rPr>
-              <a:t>10–16 sep
-</a:t>
+              <a:t>10–16 sep</a:t>
             </a:r>
+            <a:endParaRPr lang="en-US" sz="1000" dirty="0"/>
+          </a:p>
+        </p:txBody>
+      </p:sp>
+      <p:sp>
+        <p:nvSpPr>
+          <p:cNvPr id="46" name="Shape 43"/>
+          <p:cNvSpPr/>
+          <p:nvPr/>
+        </p:nvSpPr>
+        <p:spPr>
+          <a:xfrm>
+            <a:off x="4173728" y="2103120"/>
+            <a:ext cx="887984" cy="1280160"/>
+          </a:xfrm>
+          <a:prstGeom prst="roundRect">
+            <a:avLst>
+              <a:gd name="adj" fmla="val 8238"/>
+            </a:avLst>
+          </a:prstGeom>
+          <a:solidFill>
+            <a:srgbClr val="0A1A2E"/>
+          </a:solidFill>
+          <a:ln w="15875">
+            <a:solidFill>
+              <a:srgbClr val="1A2B4A"/>
+            </a:solidFill>
+            <a:prstDash val="solid"/>
+          </a:ln>
+        </p:spPr>
+      </p:sp>
+      <p:sp>
+        <p:nvSpPr>
+          <p:cNvPr id="47" name="Text 44"/>
+          <p:cNvSpPr/>
+          <p:nvPr/>
+        </p:nvSpPr>
+        <p:spPr>
+          <a:xfrm>
+            <a:off x="4228592" y="2157984"/>
+            <a:ext cx="778256" cy="1170432"/>
+          </a:xfrm>
+          <a:prstGeom prst="rect">
+            <a:avLst/>
+          </a:prstGeom>
+          <a:noFill/>
+          <a:ln/>
+        </p:spPr>
+        <p:txBody>
+          <a:bodyPr wrap="square" lIns="0" tIns="0" rIns="0" bIns="0" rtlCol="0" anchor="ctr"/>
+          <a:lstStyle/>
+          <a:p>
             <a:pPr algn="l" indent="0" marL="0">
               <a:lnSpc>
-                <a:spcPct val="105000"/>
+                <a:spcPct val="108000"/>
               </a:lnSpc>
               <a:buNone/>
             </a:pPr>
             <a:r>
-              <a:rPr lang="en-US" sz="700" dirty="0">
+              <a:rPr lang="en-US" sz="850" dirty="0">
                 <a:solidFill>
                   <a:srgbClr val="FFFFFF"/>
                 </a:solidFill>
@@ -23312,26 +23843,95 @@
                 <a:ea typeface="Arial" pitchFamily="34" charset="-122"/>
                 <a:cs typeface="Arial" pitchFamily="34" charset="-120"/>
               </a:rPr>
-              <a:t>Sprint 2 · completar + iteración DHU</a:t>
+              <a:t>Creación bcv-cosmos-db y bcv-commons-observability</a:t>
             </a:r>
-            <a:endParaRPr lang="en-US" sz="950" dirty="0"/>
+            <a:endParaRPr lang="en-US" sz="850" dirty="0"/>
           </a:p>
         </p:txBody>
       </p:sp>
       <p:sp>
         <p:nvSpPr>
-          <p:cNvPr id="30" name="Shape 27"/>
-          <p:cNvSpPr/>
-          <p:nvPr/>
-        </p:nvSpPr>
-        <p:spPr>
-          <a:xfrm>
-            <a:off x="5125720" y="1600200"/>
-            <a:ext cx="887984" cy="1042416"/>
+          <p:cNvPr id="48" name="Shape 45"/>
+          <p:cNvSpPr/>
+          <p:nvPr/>
+        </p:nvSpPr>
+        <p:spPr>
+          <a:xfrm>
+            <a:off x="4173728" y="3474720"/>
+            <a:ext cx="887984" cy="1280160"/>
           </a:xfrm>
           <a:prstGeom prst="roundRect">
             <a:avLst>
-              <a:gd name="adj" fmla="val 9268"/>
+              <a:gd name="adj" fmla="val 8238"/>
+            </a:avLst>
+          </a:prstGeom>
+          <a:solidFill>
+            <a:srgbClr val="0A1A2E"/>
+          </a:solidFill>
+          <a:ln w="15875">
+            <a:solidFill>
+              <a:srgbClr val="1A2B4A"/>
+            </a:solidFill>
+            <a:prstDash val="solid"/>
+          </a:ln>
+        </p:spPr>
+      </p:sp>
+      <p:sp>
+        <p:nvSpPr>
+          <p:cNvPr id="49" name="Text 46"/>
+          <p:cNvSpPr/>
+          <p:nvPr/>
+        </p:nvSpPr>
+        <p:spPr>
+          <a:xfrm>
+            <a:off x="4228592" y="3529584"/>
+            <a:ext cx="778256" cy="1170432"/>
+          </a:xfrm>
+          <a:prstGeom prst="rect">
+            <a:avLst/>
+          </a:prstGeom>
+          <a:noFill/>
+          <a:ln/>
+        </p:spPr>
+        <p:txBody>
+          <a:bodyPr wrap="square" lIns="0" tIns="0" rIns="0" bIns="0" rtlCol="0" anchor="ctr"/>
+          <a:lstStyle/>
+          <a:p>
+            <a:pPr algn="l" indent="0" marL="0">
+              <a:lnSpc>
+                <a:spcPct val="108000"/>
+              </a:lnSpc>
+              <a:buNone/>
+            </a:pPr>
+            <a:r>
+              <a:rPr lang="en-US" sz="850" dirty="0">
+                <a:solidFill>
+                  <a:srgbClr val="FFFFFF"/>
+                </a:solidFill>
+                <a:latin typeface="Arial" pitchFamily="34" charset="0"/>
+                <a:ea typeface="Arial" pitchFamily="34" charset="-122"/>
+                <a:cs typeface="Arial" pitchFamily="34" charset="-120"/>
+              </a:rPr>
+              <a:t>Refinar skills según feedback</a:t>
+            </a:r>
+            <a:endParaRPr lang="en-US" sz="850" dirty="0"/>
+          </a:p>
+        </p:txBody>
+      </p:sp>
+      <p:sp>
+        <p:nvSpPr>
+          <p:cNvPr id="50" name="Shape 47"/>
+          <p:cNvSpPr/>
+          <p:nvPr/>
+        </p:nvSpPr>
+        <p:spPr>
+          <a:xfrm>
+            <a:off x="5125720" y="1627632"/>
+            <a:ext cx="887984" cy="384048"/>
+          </a:xfrm>
+          <a:prstGeom prst="roundRect">
+            <a:avLst>
+              <a:gd name="adj" fmla="val 33333"/>
             </a:avLst>
           </a:prstGeom>
           <a:solidFill>
@@ -23347,14 +23947,14 @@
       </p:sp>
       <p:sp>
         <p:nvSpPr>
-          <p:cNvPr id="31" name="Text 28"/>
-          <p:cNvSpPr/>
-          <p:nvPr/>
-        </p:nvSpPr>
-        <p:spPr>
-          <a:xfrm>
-            <a:off x="5171440" y="1645920"/>
-            <a:ext cx="796544" cy="950976"/>
+          <p:cNvPr id="51" name="Text 48"/>
+          <p:cNvSpPr/>
+          <p:nvPr/>
+        </p:nvSpPr>
+        <p:spPr>
+          <a:xfrm>
+            <a:off x="5125720" y="1627632"/>
+            <a:ext cx="887984" cy="384048"/>
           </a:xfrm>
           <a:prstGeom prst="rect">
             <a:avLst/>
@@ -23363,17 +23963,17 @@
           <a:ln/>
         </p:spPr>
         <p:txBody>
-          <a:bodyPr wrap="square" lIns="0" tIns="0" rIns="0" bIns="0" rtlCol="0" anchor="t"/>
+          <a:bodyPr wrap="square" lIns="0" tIns="0" rIns="0" bIns="0" rtlCol="0" anchor="ctr"/>
           <a:lstStyle/>
           <a:p>
-            <a:pPr algn="l" indent="0" marL="0">
+            <a:pPr algn="ctr" indent="0" marL="0">
               <a:lnSpc>
-                <a:spcPct val="105000"/>
+                <a:spcPct val="100000"/>
               </a:lnSpc>
               <a:buNone/>
             </a:pPr>
             <a:r>
-              <a:rPr lang="en-US" sz="950" b="1" dirty="0">
+              <a:rPr lang="en-US" sz="1000" b="1" dirty="0">
                 <a:solidFill>
                   <a:srgbClr val="FFFFFF"/>
                 </a:solidFill>
@@ -23384,9 +23984,9 @@
               <a:t>SEM 6
 </a:t>
             </a:r>
-            <a:pPr algn="l" indent="0" marL="0">
+            <a:pPr algn="ctr" indent="0" marL="0">
               <a:lnSpc>
-                <a:spcPct val="105000"/>
+                <a:spcPct val="100000"/>
               </a:lnSpc>
               <a:buNone/>
             </a:pPr>
@@ -23399,17 +23999,68 @@
                 <a:ea typeface="Arial" pitchFamily="34" charset="-122"/>
                 <a:cs typeface="Arial" pitchFamily="34" charset="-120"/>
               </a:rPr>
-              <a:t>17–23 sep
-</a:t>
+              <a:t>17–23 sep</a:t>
             </a:r>
+            <a:endParaRPr lang="en-US" sz="1000" dirty="0"/>
+          </a:p>
+        </p:txBody>
+      </p:sp>
+      <p:sp>
+        <p:nvSpPr>
+          <p:cNvPr id="52" name="Shape 49"/>
+          <p:cNvSpPr/>
+          <p:nvPr/>
+        </p:nvSpPr>
+        <p:spPr>
+          <a:xfrm>
+            <a:off x="5125720" y="2103120"/>
+            <a:ext cx="887984" cy="1280160"/>
+          </a:xfrm>
+          <a:prstGeom prst="roundRect">
+            <a:avLst>
+              <a:gd name="adj" fmla="val 8238"/>
+            </a:avLst>
+          </a:prstGeom>
+          <a:solidFill>
+            <a:srgbClr val="0A1A2E"/>
+          </a:solidFill>
+          <a:ln w="15875">
+            <a:solidFill>
+              <a:srgbClr val="1A2B4A"/>
+            </a:solidFill>
+            <a:prstDash val="solid"/>
+          </a:ln>
+        </p:spPr>
+      </p:sp>
+      <p:sp>
+        <p:nvSpPr>
+          <p:cNvPr id="53" name="Text 50"/>
+          <p:cNvSpPr/>
+          <p:nvPr/>
+        </p:nvSpPr>
+        <p:spPr>
+          <a:xfrm>
+            <a:off x="5180584" y="2157984"/>
+            <a:ext cx="778256" cy="1170432"/>
+          </a:xfrm>
+          <a:prstGeom prst="rect">
+            <a:avLst/>
+          </a:prstGeom>
+          <a:noFill/>
+          <a:ln/>
+        </p:spPr>
+        <p:txBody>
+          <a:bodyPr wrap="square" lIns="0" tIns="0" rIns="0" bIns="0" rtlCol="0" anchor="ctr"/>
+          <a:lstStyle/>
+          <a:p>
             <a:pPr algn="l" indent="0" marL="0">
               <a:lnSpc>
-                <a:spcPct val="105000"/>
+                <a:spcPct val="108000"/>
               </a:lnSpc>
               <a:buNone/>
             </a:pPr>
             <a:r>
-              <a:rPr lang="en-US" sz="700" dirty="0">
+              <a:rPr lang="en-US" sz="850" dirty="0">
                 <a:solidFill>
                   <a:srgbClr val="FFFFFF"/>
                 </a:solidFill>
@@ -23417,15 +24068,84 @@
                 <a:ea typeface="Arial" pitchFamily="34" charset="-122"/>
                 <a:cs typeface="Arial" pitchFamily="34" charset="-120"/>
               </a:rPr>
-              <a:t>Sprint 3 · completar 13 skills + implementación</a:t>
+              <a:t>Creación bcv-testing (se completan los 13 skills)</a:t>
             </a:r>
-            <a:endParaRPr lang="en-US" sz="950" dirty="0"/>
+            <a:endParaRPr lang="en-US" sz="850" dirty="0"/>
           </a:p>
         </p:txBody>
       </p:sp>
       <p:sp>
         <p:nvSpPr>
-          <p:cNvPr id="32" name="Shape 29"/>
+          <p:cNvPr id="54" name="Shape 51"/>
+          <p:cNvSpPr/>
+          <p:nvPr/>
+        </p:nvSpPr>
+        <p:spPr>
+          <a:xfrm>
+            <a:off x="5125720" y="3474720"/>
+            <a:ext cx="887984" cy="1280160"/>
+          </a:xfrm>
+          <a:prstGeom prst="roundRect">
+            <a:avLst>
+              <a:gd name="adj" fmla="val 8238"/>
+            </a:avLst>
+          </a:prstGeom>
+          <a:solidFill>
+            <a:srgbClr val="0A1A2E"/>
+          </a:solidFill>
+          <a:ln w="15875">
+            <a:solidFill>
+              <a:srgbClr val="1A2B4A"/>
+            </a:solidFill>
+            <a:prstDash val="solid"/>
+          </a:ln>
+        </p:spPr>
+      </p:sp>
+      <p:sp>
+        <p:nvSpPr>
+          <p:cNvPr id="55" name="Text 52"/>
+          <p:cNvSpPr/>
+          <p:nvPr/>
+        </p:nvSpPr>
+        <p:spPr>
+          <a:xfrm>
+            <a:off x="5180584" y="3529584"/>
+            <a:ext cx="778256" cy="1170432"/>
+          </a:xfrm>
+          <a:prstGeom prst="rect">
+            <a:avLst/>
+          </a:prstGeom>
+          <a:noFill/>
+          <a:ln/>
+        </p:spPr>
+        <p:txBody>
+          <a:bodyPr wrap="square" lIns="0" tIns="0" rIns="0" bIns="0" rtlCol="0" anchor="ctr"/>
+          <a:lstStyle/>
+          <a:p>
+            <a:pPr algn="l" indent="0" marL="0">
+              <a:lnSpc>
+                <a:spcPct val="108000"/>
+              </a:lnSpc>
+              <a:buNone/>
+            </a:pPr>
+            <a:r>
+              <a:rPr lang="en-US" sz="850" dirty="0">
+                <a:solidFill>
+                  <a:srgbClr val="FFFFFF"/>
+                </a:solidFill>
+                <a:latin typeface="Arial" pitchFamily="34" charset="0"/>
+                <a:ea typeface="Arial" pitchFamily="34" charset="-122"/>
+                <a:cs typeface="Arial" pitchFamily="34" charset="-120"/>
+              </a:rPr>
+              <a:t>Generar DHU técnica (bcv-dhu-writer)</a:t>
+            </a:r>
+            <a:endParaRPr lang="en-US" sz="850" dirty="0"/>
+          </a:p>
+        </p:txBody>
+      </p:sp>
+      <p:sp>
+        <p:nvSpPr>
+          <p:cNvPr id="56" name="Shape 53"/>
           <p:cNvSpPr/>
           <p:nvPr/>
         </p:nvSpPr>
@@ -23452,7 +24172,7 @@
       </p:sp>
       <p:sp>
         <p:nvSpPr>
-          <p:cNvPr id="33" name="Text 30"/>
+          <p:cNvPr id="57" name="Text 54"/>
           <p:cNvSpPr/>
           <p:nvPr/>
         </p:nvSpPr>
@@ -23491,7 +24211,7 @@
       </p:sp>
       <p:sp>
         <p:nvSpPr>
-          <p:cNvPr id="34" name="Text 31"/>
+          <p:cNvPr id="58" name="Text 55"/>
           <p:cNvSpPr/>
           <p:nvPr/>
         </p:nvSpPr>
@@ -23530,18 +24250,18 @@
       </p:sp>
       <p:sp>
         <p:nvSpPr>
-          <p:cNvPr id="35" name="Shape 32"/>
-          <p:cNvSpPr/>
-          <p:nvPr/>
-        </p:nvSpPr>
-        <p:spPr>
-          <a:xfrm>
-            <a:off x="6077712" y="1600200"/>
-            <a:ext cx="887984" cy="1042416"/>
+          <p:cNvPr id="59" name="Shape 56"/>
+          <p:cNvSpPr/>
+          <p:nvPr/>
+        </p:nvSpPr>
+        <p:spPr>
+          <a:xfrm>
+            <a:off x="6077712" y="1627632"/>
+            <a:ext cx="887984" cy="384048"/>
           </a:xfrm>
           <a:prstGeom prst="roundRect">
             <a:avLst>
-              <a:gd name="adj" fmla="val 9268"/>
+              <a:gd name="adj" fmla="val 33333"/>
             </a:avLst>
           </a:prstGeom>
           <a:solidFill>
@@ -23557,14 +24277,14 @@
       </p:sp>
       <p:sp>
         <p:nvSpPr>
-          <p:cNvPr id="36" name="Text 33"/>
-          <p:cNvSpPr/>
-          <p:nvPr/>
-        </p:nvSpPr>
-        <p:spPr>
-          <a:xfrm>
-            <a:off x="6123432" y="1645920"/>
-            <a:ext cx="796544" cy="950976"/>
+          <p:cNvPr id="60" name="Text 57"/>
+          <p:cNvSpPr/>
+          <p:nvPr/>
+        </p:nvSpPr>
+        <p:spPr>
+          <a:xfrm>
+            <a:off x="6077712" y="1627632"/>
+            <a:ext cx="887984" cy="384048"/>
           </a:xfrm>
           <a:prstGeom prst="rect">
             <a:avLst/>
@@ -23573,17 +24293,17 @@
           <a:ln/>
         </p:spPr>
         <p:txBody>
-          <a:bodyPr wrap="square" lIns="0" tIns="0" rIns="0" bIns="0" rtlCol="0" anchor="t"/>
+          <a:bodyPr wrap="square" lIns="0" tIns="0" rIns="0" bIns="0" rtlCol="0" anchor="ctr"/>
           <a:lstStyle/>
           <a:p>
-            <a:pPr algn="l" indent="0" marL="0">
+            <a:pPr algn="ctr" indent="0" marL="0">
               <a:lnSpc>
-                <a:spcPct val="105000"/>
+                <a:spcPct val="100000"/>
               </a:lnSpc>
               <a:buNone/>
             </a:pPr>
             <a:r>
-              <a:rPr lang="en-US" sz="950" b="1" dirty="0">
+              <a:rPr lang="en-US" sz="1000" b="1" dirty="0">
                 <a:solidFill>
                   <a:srgbClr val="FFFFFF"/>
                 </a:solidFill>
@@ -23594,9 +24314,9 @@
               <a:t>SEM 7
 </a:t>
             </a:r>
-            <a:pPr algn="l" indent="0" marL="0">
+            <a:pPr algn="ctr" indent="0" marL="0">
               <a:lnSpc>
-                <a:spcPct val="105000"/>
+                <a:spcPct val="100000"/>
               </a:lnSpc>
               <a:buNone/>
             </a:pPr>
@@ -23609,17 +24329,68 @@
                 <a:ea typeface="Arial" pitchFamily="34" charset="-122"/>
                 <a:cs typeface="Arial" pitchFamily="34" charset="-120"/>
               </a:rPr>
-              <a:t>24–30 sep
-</a:t>
+              <a:t>24–30 sep</a:t>
             </a:r>
+            <a:endParaRPr lang="en-US" sz="1000" dirty="0"/>
+          </a:p>
+        </p:txBody>
+      </p:sp>
+      <p:sp>
+        <p:nvSpPr>
+          <p:cNvPr id="61" name="Shape 58"/>
+          <p:cNvSpPr/>
+          <p:nvPr/>
+        </p:nvSpPr>
+        <p:spPr>
+          <a:xfrm>
+            <a:off x="6077712" y="2103120"/>
+            <a:ext cx="887984" cy="1280160"/>
+          </a:xfrm>
+          <a:prstGeom prst="roundRect">
+            <a:avLst>
+              <a:gd name="adj" fmla="val 8238"/>
+            </a:avLst>
+          </a:prstGeom>
+          <a:solidFill>
+            <a:srgbClr val="0A1A2E"/>
+          </a:solidFill>
+          <a:ln w="15875">
+            <a:solidFill>
+              <a:srgbClr val="1A2B4A"/>
+            </a:solidFill>
+            <a:prstDash val="solid"/>
+          </a:ln>
+        </p:spPr>
+      </p:sp>
+      <p:sp>
+        <p:nvSpPr>
+          <p:cNvPr id="62" name="Text 59"/>
+          <p:cNvSpPr/>
+          <p:nvPr/>
+        </p:nvSpPr>
+        <p:spPr>
+          <a:xfrm>
+            <a:off x="6132576" y="2157984"/>
+            <a:ext cx="778256" cy="1170432"/>
+          </a:xfrm>
+          <a:prstGeom prst="rect">
+            <a:avLst/>
+          </a:prstGeom>
+          <a:noFill/>
+          <a:ln/>
+        </p:spPr>
+        <p:txBody>
+          <a:bodyPr wrap="square" lIns="0" tIns="0" rIns="0" bIns="0" rtlCol="0" anchor="ctr"/>
+          <a:lstStyle/>
+          <a:p>
             <a:pPr algn="l" indent="0" marL="0">
               <a:lnSpc>
-                <a:spcPct val="105000"/>
+                <a:spcPct val="108000"/>
               </a:lnSpc>
               <a:buNone/>
             </a:pPr>
             <a:r>
-              <a:rPr lang="en-US" sz="700" dirty="0">
+              <a:rPr lang="en-US" sz="850" dirty="0">
                 <a:solidFill>
                   <a:srgbClr val="FFFFFF"/>
                 </a:solidFill>
@@ -23627,26 +24398,95 @@
                 <a:ea typeface="Arial" pitchFamily="34" charset="-122"/>
                 <a:cs typeface="Arial" pitchFamily="34" charset="-120"/>
               </a:rPr>
-              <a:t>Sprint 4 · validación equipo dev banco</a:t>
+              <a:t>Validación con equipo dev del banco</a:t>
             </a:r>
-            <a:endParaRPr lang="en-US" sz="950" dirty="0"/>
+            <a:endParaRPr lang="en-US" sz="850" dirty="0"/>
           </a:p>
         </p:txBody>
       </p:sp>
       <p:sp>
         <p:nvSpPr>
-          <p:cNvPr id="37" name="Shape 34"/>
-          <p:cNvSpPr/>
-          <p:nvPr/>
-        </p:nvSpPr>
-        <p:spPr>
-          <a:xfrm>
-            <a:off x="7029704" y="1600200"/>
-            <a:ext cx="887984" cy="1042416"/>
+          <p:cNvPr id="63" name="Shape 60"/>
+          <p:cNvSpPr/>
+          <p:nvPr/>
+        </p:nvSpPr>
+        <p:spPr>
+          <a:xfrm>
+            <a:off x="6077712" y="3474720"/>
+            <a:ext cx="887984" cy="1280160"/>
           </a:xfrm>
           <a:prstGeom prst="roundRect">
             <a:avLst>
-              <a:gd name="adj" fmla="val 9268"/>
+              <a:gd name="adj" fmla="val 8238"/>
+            </a:avLst>
+          </a:prstGeom>
+          <a:solidFill>
+            <a:srgbClr val="0A1A2E"/>
+          </a:solidFill>
+          <a:ln w="15875">
+            <a:solidFill>
+              <a:srgbClr val="1A2B4A"/>
+            </a:solidFill>
+            <a:prstDash val="solid"/>
+          </a:ln>
+        </p:spPr>
+      </p:sp>
+      <p:sp>
+        <p:nvSpPr>
+          <p:cNvPr id="64" name="Text 61"/>
+          <p:cNvSpPr/>
+          <p:nvPr/>
+        </p:nvSpPr>
+        <p:spPr>
+          <a:xfrm>
+            <a:off x="6132576" y="3529584"/>
+            <a:ext cx="778256" cy="1170432"/>
+          </a:xfrm>
+          <a:prstGeom prst="rect">
+            <a:avLst/>
+          </a:prstGeom>
+          <a:noFill/>
+          <a:ln/>
+        </p:spPr>
+        <p:txBody>
+          <a:bodyPr wrap="square" lIns="0" tIns="0" rIns="0" bIns="0" rtlCol="0" anchor="ctr"/>
+          <a:lstStyle/>
+          <a:p>
+            <a:pPr algn="l" indent="0" marL="0">
+              <a:lnSpc>
+                <a:spcPct val="108000"/>
+              </a:lnSpc>
+              <a:buNone/>
+            </a:pPr>
+            <a:r>
+              <a:rPr lang="en-US" sz="850" dirty="0">
+                <a:solidFill>
+                  <a:srgbClr val="FFFFFF"/>
+                </a:solidFill>
+                <a:latin typeface="Arial" pitchFamily="34" charset="0"/>
+                <a:ea typeface="Arial" pitchFamily="34" charset="-122"/>
+                <a:cs typeface="Arial" pitchFamily="34" charset="-120"/>
+              </a:rPr>
+              <a:t>Ciclo: ajustar → regenerar → revalidar</a:t>
+            </a:r>
+            <a:endParaRPr lang="en-US" sz="850" dirty="0"/>
+          </a:p>
+        </p:txBody>
+      </p:sp>
+      <p:sp>
+        <p:nvSpPr>
+          <p:cNvPr id="65" name="Shape 62"/>
+          <p:cNvSpPr/>
+          <p:nvPr/>
+        </p:nvSpPr>
+        <p:spPr>
+          <a:xfrm>
+            <a:off x="7029704" y="1627632"/>
+            <a:ext cx="887984" cy="384048"/>
+          </a:xfrm>
+          <a:prstGeom prst="roundRect">
+            <a:avLst>
+              <a:gd name="adj" fmla="val 33333"/>
             </a:avLst>
           </a:prstGeom>
           <a:solidFill>
@@ -23662,14 +24502,14 @@
       </p:sp>
       <p:sp>
         <p:nvSpPr>
-          <p:cNvPr id="38" name="Text 35"/>
-          <p:cNvSpPr/>
-          <p:nvPr/>
-        </p:nvSpPr>
-        <p:spPr>
-          <a:xfrm>
-            <a:off x="7075424" y="1645920"/>
-            <a:ext cx="796544" cy="950976"/>
+          <p:cNvPr id="66" name="Text 63"/>
+          <p:cNvSpPr/>
+          <p:nvPr/>
+        </p:nvSpPr>
+        <p:spPr>
+          <a:xfrm>
+            <a:off x="7029704" y="1627632"/>
+            <a:ext cx="887984" cy="384048"/>
           </a:xfrm>
           <a:prstGeom prst="rect">
             <a:avLst/>
@@ -23678,17 +24518,17 @@
           <a:ln/>
         </p:spPr>
         <p:txBody>
-          <a:bodyPr wrap="square" lIns="0" tIns="0" rIns="0" bIns="0" rtlCol="0" anchor="t"/>
+          <a:bodyPr wrap="square" lIns="0" tIns="0" rIns="0" bIns="0" rtlCol="0" anchor="ctr"/>
           <a:lstStyle/>
           <a:p>
-            <a:pPr algn="l" indent="0" marL="0">
+            <a:pPr algn="ctr" indent="0" marL="0">
               <a:lnSpc>
-                <a:spcPct val="105000"/>
+                <a:spcPct val="100000"/>
               </a:lnSpc>
               <a:buNone/>
             </a:pPr>
             <a:r>
-              <a:rPr lang="en-US" sz="950" b="1" dirty="0">
+              <a:rPr lang="en-US" sz="1000" b="1" dirty="0">
                 <a:solidFill>
                   <a:srgbClr val="FFFFFF"/>
                 </a:solidFill>
@@ -23699,9 +24539,9 @@
               <a:t>SEM 8
 </a:t>
             </a:r>
-            <a:pPr algn="l" indent="0" marL="0">
+            <a:pPr algn="ctr" indent="0" marL="0">
               <a:lnSpc>
-                <a:spcPct val="105000"/>
+                <a:spcPct val="100000"/>
               </a:lnSpc>
               <a:buNone/>
             </a:pPr>
@@ -23714,17 +24554,68 @@
                 <a:ea typeface="Arial" pitchFamily="34" charset="-122"/>
                 <a:cs typeface="Arial" pitchFamily="34" charset="-120"/>
               </a:rPr>
-              <a:t>01–07 oct
-</a:t>
+              <a:t>01–07 oct</a:t>
             </a:r>
+            <a:endParaRPr lang="en-US" sz="1000" dirty="0"/>
+          </a:p>
+        </p:txBody>
+      </p:sp>
+      <p:sp>
+        <p:nvSpPr>
+          <p:cNvPr id="67" name="Shape 64"/>
+          <p:cNvSpPr/>
+          <p:nvPr/>
+        </p:nvSpPr>
+        <p:spPr>
+          <a:xfrm>
+            <a:off x="7029704" y="2103120"/>
+            <a:ext cx="887984" cy="1280160"/>
+          </a:xfrm>
+          <a:prstGeom prst="roundRect">
+            <a:avLst>
+              <a:gd name="adj" fmla="val 8238"/>
+            </a:avLst>
+          </a:prstGeom>
+          <a:solidFill>
+            <a:srgbClr val="0A1A2E"/>
+          </a:solidFill>
+          <a:ln w="15875">
+            <a:solidFill>
+              <a:srgbClr val="1A2B4A"/>
+            </a:solidFill>
+            <a:prstDash val="solid"/>
+          </a:ln>
+        </p:spPr>
+      </p:sp>
+      <p:sp>
+        <p:nvSpPr>
+          <p:cNvPr id="68" name="Text 65"/>
+          <p:cNvSpPr/>
+          <p:nvPr/>
+        </p:nvSpPr>
+        <p:spPr>
+          <a:xfrm>
+            <a:off x="7084568" y="2157984"/>
+            <a:ext cx="778256" cy="1170432"/>
+          </a:xfrm>
+          <a:prstGeom prst="rect">
+            <a:avLst/>
+          </a:prstGeom>
+          <a:noFill/>
+          <a:ln/>
+        </p:spPr>
+        <p:txBody>
+          <a:bodyPr wrap="square" lIns="0" tIns="0" rIns="0" bIns="0" rtlCol="0" anchor="ctr"/>
+          <a:lstStyle/>
+          <a:p>
             <a:pPr algn="l" indent="0" marL="0">
               <a:lnSpc>
-                <a:spcPct val="105000"/>
+                <a:spcPct val="108000"/>
               </a:lnSpc>
               <a:buNone/>
             </a:pPr>
             <a:r>
-              <a:rPr lang="en-US" sz="700" dirty="0">
+              <a:rPr lang="en-US" sz="850" dirty="0">
                 <a:solidFill>
                   <a:srgbClr val="FFFFFF"/>
                 </a:solidFill>
@@ -23732,15 +24623,84 @@
                 <a:ea typeface="Arial" pitchFamily="34" charset="-122"/>
                 <a:cs typeface="Arial" pitchFamily="34" charset="-120"/>
               </a:rPr>
-              <a:t>Sprint 4 · estabilización y cierre</a:t>
+              <a:t>Estabilización final de skills</a:t>
             </a:r>
-            <a:endParaRPr lang="en-US" sz="950" dirty="0"/>
+            <a:endParaRPr lang="en-US" sz="850" dirty="0"/>
           </a:p>
         </p:txBody>
       </p:sp>
       <p:sp>
         <p:nvSpPr>
-          <p:cNvPr id="39" name="Shape 36"/>
+          <p:cNvPr id="69" name="Shape 66"/>
+          <p:cNvSpPr/>
+          <p:nvPr/>
+        </p:nvSpPr>
+        <p:spPr>
+          <a:xfrm>
+            <a:off x="7029704" y="3474720"/>
+            <a:ext cx="887984" cy="1280160"/>
+          </a:xfrm>
+          <a:prstGeom prst="roundRect">
+            <a:avLst>
+              <a:gd name="adj" fmla="val 8238"/>
+            </a:avLst>
+          </a:prstGeom>
+          <a:solidFill>
+            <a:srgbClr val="0A1A2E"/>
+          </a:solidFill>
+          <a:ln w="15875">
+            <a:solidFill>
+              <a:srgbClr val="1A2B4A"/>
+            </a:solidFill>
+            <a:prstDash val="solid"/>
+          </a:ln>
+        </p:spPr>
+      </p:sp>
+      <p:sp>
+        <p:nvSpPr>
+          <p:cNvPr id="70" name="Text 67"/>
+          <p:cNvSpPr/>
+          <p:nvPr/>
+        </p:nvSpPr>
+        <p:spPr>
+          <a:xfrm>
+            <a:off x="7084568" y="3529584"/>
+            <a:ext cx="778256" cy="1170432"/>
+          </a:xfrm>
+          <a:prstGeom prst="rect">
+            <a:avLst/>
+          </a:prstGeom>
+          <a:noFill/>
+          <a:ln/>
+        </p:spPr>
+        <p:txBody>
+          <a:bodyPr wrap="square" lIns="0" tIns="0" rIns="0" bIns="0" rtlCol="0" anchor="ctr"/>
+          <a:lstStyle/>
+          <a:p>
+            <a:pPr algn="l" indent="0" marL="0">
+              <a:lnSpc>
+                <a:spcPct val="108000"/>
+              </a:lnSpc>
+              <a:buNone/>
+            </a:pPr>
+            <a:r>
+              <a:rPr lang="en-US" sz="850" dirty="0">
+                <a:solidFill>
+                  <a:srgbClr val="FFFFFF"/>
+                </a:solidFill>
+                <a:latin typeface="Arial" pitchFamily="34" charset="0"/>
+                <a:ea typeface="Arial" pitchFamily="34" charset="-122"/>
+                <a:cs typeface="Arial" pitchFamily="34" charset="-120"/>
+              </a:rPr>
+              <a:t>Documentación, onboarding y demo al cliente</a:t>
+            </a:r>
+            <a:endParaRPr lang="en-US" sz="850" dirty="0"/>
+          </a:p>
+        </p:txBody>
+      </p:sp>
+      <p:sp>
+        <p:nvSpPr>
+          <p:cNvPr id="71" name="Shape 68"/>
           <p:cNvSpPr/>
           <p:nvPr/>
         </p:nvSpPr>
@@ -23767,7 +24727,7 @@
       </p:sp>
       <p:sp>
         <p:nvSpPr>
-          <p:cNvPr id="40" name="Text 37"/>
+          <p:cNvPr id="72" name="Text 69"/>
           <p:cNvSpPr/>
           <p:nvPr/>
         </p:nvSpPr>
@@ -23806,7 +24766,7 @@
       </p:sp>
       <p:sp>
         <p:nvSpPr>
-          <p:cNvPr id="41" name="Text 38"/>
+          <p:cNvPr id="73" name="Text 70"/>
           <p:cNvSpPr/>
           <p:nvPr/>
         </p:nvSpPr>
@@ -23845,18 +24805,18 @@
       </p:sp>
       <p:sp>
         <p:nvSpPr>
-          <p:cNvPr id="42" name="Shape 39"/>
-          <p:cNvSpPr/>
-          <p:nvPr/>
-        </p:nvSpPr>
-        <p:spPr>
-          <a:xfrm>
-            <a:off x="7981696" y="1600200"/>
-            <a:ext cx="887984" cy="1042416"/>
+          <p:cNvPr id="74" name="Shape 71"/>
+          <p:cNvSpPr/>
+          <p:nvPr/>
+        </p:nvSpPr>
+        <p:spPr>
+          <a:xfrm>
+            <a:off x="7981696" y="1627632"/>
+            <a:ext cx="887984" cy="384048"/>
           </a:xfrm>
           <a:prstGeom prst="roundRect">
             <a:avLst>
-              <a:gd name="adj" fmla="val 9268"/>
+              <a:gd name="adj" fmla="val 33333"/>
             </a:avLst>
           </a:prstGeom>
           <a:solidFill>
@@ -23872,14 +24832,14 @@
       </p:sp>
       <p:sp>
         <p:nvSpPr>
-          <p:cNvPr id="43" name="Text 40"/>
-          <p:cNvSpPr/>
-          <p:nvPr/>
-        </p:nvSpPr>
-        <p:spPr>
-          <a:xfrm>
-            <a:off x="8027416" y="1645920"/>
-            <a:ext cx="796544" cy="950976"/>
+          <p:cNvPr id="75" name="Text 72"/>
+          <p:cNvSpPr/>
+          <p:nvPr/>
+        </p:nvSpPr>
+        <p:spPr>
+          <a:xfrm>
+            <a:off x="7981696" y="1627632"/>
+            <a:ext cx="887984" cy="384048"/>
           </a:xfrm>
           <a:prstGeom prst="rect">
             <a:avLst/>
@@ -23888,17 +24848,17 @@
           <a:ln/>
         </p:spPr>
         <p:txBody>
-          <a:bodyPr wrap="square" lIns="0" tIns="0" rIns="0" bIns="0" rtlCol="0" anchor="t"/>
+          <a:bodyPr wrap="square" lIns="0" tIns="0" rIns="0" bIns="0" rtlCol="0" anchor="ctr"/>
           <a:lstStyle/>
           <a:p>
-            <a:pPr algn="l" indent="0" marL="0">
+            <a:pPr algn="ctr" indent="0" marL="0">
               <a:lnSpc>
-                <a:spcPct val="105000"/>
+                <a:spcPct val="100000"/>
               </a:lnSpc>
               <a:buNone/>
             </a:pPr>
             <a:r>
-              <a:rPr lang="en-US" sz="950" b="1" dirty="0">
+              <a:rPr lang="en-US" sz="1000" b="1" dirty="0">
                 <a:solidFill>
                   <a:srgbClr val="FFFFFF"/>
                 </a:solidFill>
@@ -23909,9 +24869,9 @@
               <a:t>SEM C
 </a:t>
             </a:r>
-            <a:pPr algn="l" indent="0" marL="0">
+            <a:pPr algn="ctr" indent="0" marL="0">
               <a:lnSpc>
-                <a:spcPct val="105000"/>
+                <a:spcPct val="100000"/>
               </a:lnSpc>
               <a:buNone/>
             </a:pPr>
@@ -23924,17 +24884,68 @@
                 <a:ea typeface="Arial" pitchFamily="34" charset="-122"/>
                 <a:cs typeface="Arial" pitchFamily="34" charset="-120"/>
               </a:rPr>
-              <a:t>08–09 oct
-</a:t>
+              <a:t>08–09 oct</a:t>
             </a:r>
+            <a:endParaRPr lang="en-US" sz="1000" dirty="0"/>
+          </a:p>
+        </p:txBody>
+      </p:sp>
+      <p:sp>
+        <p:nvSpPr>
+          <p:cNvPr id="76" name="Shape 73"/>
+          <p:cNvSpPr/>
+          <p:nvPr/>
+        </p:nvSpPr>
+        <p:spPr>
+          <a:xfrm>
+            <a:off x="7981696" y="2103120"/>
+            <a:ext cx="887984" cy="1280160"/>
+          </a:xfrm>
+          <a:prstGeom prst="roundRect">
+            <a:avLst>
+              <a:gd name="adj" fmla="val 8238"/>
+            </a:avLst>
+          </a:prstGeom>
+          <a:solidFill>
+            <a:srgbClr val="0A1A2E"/>
+          </a:solidFill>
+          <a:ln w="15875">
+            <a:solidFill>
+              <a:srgbClr val="1A2B4A"/>
+            </a:solidFill>
+            <a:prstDash val="solid"/>
+          </a:ln>
+        </p:spPr>
+      </p:sp>
+      <p:sp>
+        <p:nvSpPr>
+          <p:cNvPr id="77" name="Text 74"/>
+          <p:cNvSpPr/>
+          <p:nvPr/>
+        </p:nvSpPr>
+        <p:spPr>
+          <a:xfrm>
+            <a:off x="8036560" y="2157984"/>
+            <a:ext cx="778256" cy="1170432"/>
+          </a:xfrm>
+          <a:prstGeom prst="rect">
+            <a:avLst/>
+          </a:prstGeom>
+          <a:noFill/>
+          <a:ln/>
+        </p:spPr>
+        <p:txBody>
+          <a:bodyPr wrap="square" lIns="0" tIns="0" rIns="0" bIns="0" rtlCol="0" anchor="ctr"/>
+          <a:lstStyle/>
+          <a:p>
             <a:pPr algn="l" indent="0" marL="0">
               <a:lnSpc>
-                <a:spcPct val="105000"/>
+                <a:spcPct val="108000"/>
               </a:lnSpc>
               <a:buNone/>
             </a:pPr>
             <a:r>
-              <a:rPr lang="en-US" sz="700" dirty="0">
+              <a:rPr lang="en-US" sz="850" dirty="0">
                 <a:solidFill>
                   <a:srgbClr val="FFFFFF"/>
                 </a:solidFill>
@@ -23942,32 +24953,32 @@
                 <a:ea typeface="Arial" pitchFamily="34" charset="-122"/>
                 <a:cs typeface="Arial" pitchFamily="34" charset="-120"/>
               </a:rPr>
-              <a:t>Cierre de entregables</a:t>
+              <a:t>Cierre final de entregables</a:t>
             </a:r>
-            <a:endParaRPr lang="en-US" sz="950" dirty="0"/>
+            <a:endParaRPr lang="en-US" sz="850" dirty="0"/>
           </a:p>
         </p:txBody>
       </p:sp>
       <p:sp>
         <p:nvSpPr>
-          <p:cNvPr id="44" name="Shape 41"/>
-          <p:cNvSpPr/>
-          <p:nvPr/>
-        </p:nvSpPr>
-        <p:spPr>
-          <a:xfrm>
-            <a:off x="365760" y="2798064"/>
-            <a:ext cx="4183380" cy="1188720"/>
+          <p:cNvPr id="78" name="Shape 75"/>
+          <p:cNvSpPr/>
+          <p:nvPr/>
+        </p:nvSpPr>
+        <p:spPr>
+          <a:xfrm>
+            <a:off x="7981696" y="3474720"/>
+            <a:ext cx="887984" cy="1280160"/>
           </a:xfrm>
           <a:prstGeom prst="roundRect">
             <a:avLst>
-              <a:gd name="adj" fmla="val 4615"/>
+              <a:gd name="adj" fmla="val 8238"/>
             </a:avLst>
           </a:prstGeom>
           <a:solidFill>
-            <a:srgbClr val="112240"/>
+            <a:srgbClr val="0A1A2E"/>
           </a:solidFill>
-          <a:ln w="12700">
+          <a:ln w="15875">
             <a:solidFill>
               <a:srgbClr val="1A2B4A"/>
             </a:solidFill>
@@ -23977,14 +24988,14 @@
       </p:sp>
       <p:sp>
         <p:nvSpPr>
-          <p:cNvPr id="45" name="Text 42"/>
-          <p:cNvSpPr/>
-          <p:nvPr/>
-        </p:nvSpPr>
-        <p:spPr>
-          <a:xfrm>
-            <a:off x="566928" y="2889504"/>
-            <a:ext cx="3781044" cy="219456"/>
+          <p:cNvPr id="79" name="Text 76"/>
+          <p:cNvSpPr/>
+          <p:nvPr/>
+        </p:nvSpPr>
+        <p:spPr>
+          <a:xfrm>
+            <a:off x="8036560" y="3529584"/>
+            <a:ext cx="778256" cy="1170432"/>
           </a:xfrm>
           <a:prstGeom prst="rect">
             <a:avLst/>
@@ -23996,609 +25007,30 @@
           <a:bodyPr wrap="square" lIns="0" tIns="0" rIns="0" bIns="0" rtlCol="0" anchor="ctr"/>
           <a:lstStyle/>
           <a:p>
-            <a:pPr indent="0" marL="0">
-              <a:buNone/>
-            </a:pPr>
-            <a:r>
-              <a:rPr lang="en-US" sz="1000" b="1" dirty="0">
-                <a:solidFill>
-                  <a:srgbClr val="00DFED"/>
-                </a:solidFill>
-                <a:latin typeface="Noto Sans" pitchFamily="34" charset="0"/>
-                <a:ea typeface="Noto Sans" pitchFamily="34" charset="-122"/>
-                <a:cs typeface="Noto Sans" pitchFamily="34" charset="-120"/>
-              </a:rPr>
-              <a:t>HITO — SEMANA 2 (SPRINT 1, 20–26 AGO)</a:t>
-            </a:r>
-            <a:endParaRPr lang="en-US" sz="1000" dirty="0"/>
-          </a:p>
-        </p:txBody>
-      </p:sp>
-      <p:sp>
-        <p:nvSpPr>
-          <p:cNvPr id="46" name="Text 43"/>
-          <p:cNvSpPr/>
-          <p:nvPr/>
-        </p:nvSpPr>
-        <p:spPr>
-          <a:xfrm>
-            <a:off x="566928" y="3127248"/>
-            <a:ext cx="3781044" cy="768096"/>
-          </a:xfrm>
-          <a:prstGeom prst="rect">
-            <a:avLst/>
-          </a:prstGeom>
-          <a:noFill/>
-          <a:ln/>
-        </p:spPr>
-        <p:txBody>
-          <a:bodyPr wrap="square" lIns="0" tIns="0" rIns="0" bIns="0" rtlCol="0" anchor="ctr"/>
-          <a:lstStyle/>
-          <a:p>
-            <a:pPr indent="0" marL="0">
+            <a:pPr algn="l" indent="0" marL="0">
               <a:lnSpc>
-                <a:spcPct val="100000"/>
+                <a:spcPct val="108000"/>
               </a:lnSpc>
               <a:buNone/>
             </a:pPr>
             <a:r>
-              <a:rPr lang="en-US" sz="800" dirty="0">
+              <a:rPr lang="en-US" sz="850" dirty="0">
                 <a:solidFill>
-                  <a:srgbClr val="D6D6D6"/>
+                  <a:srgbClr val="FFFFFF"/>
                 </a:solidFill>
                 <a:latin typeface="Arial" pitchFamily="34" charset="0"/>
                 <a:ea typeface="Arial" pitchFamily="34" charset="-122"/>
                 <a:cs typeface="Arial" pitchFamily="34" charset="-120"/>
               </a:rPr>
-              <a:t>Sprint 1 (skills 1–5): se adoptó graphify y se crearon los skills del pipeline (bcv-hu-context-analyzer, bcv-dhu-writer, bcv-hu-implementer) + arranque de bcv-hexagonal-architecture y bcv-java-spring-boot. Primer ejercicio con Fernando Camargo: ~2 h vs ~8 h (1 día) de la forma tradicional.</a:t>
+              <a:t>Traspaso a cargo de Oscar</a:t>
             </a:r>
-            <a:endParaRPr lang="en-US" sz="800" dirty="0"/>
+            <a:endParaRPr lang="en-US" sz="850" dirty="0"/>
           </a:p>
         </p:txBody>
       </p:sp>
-      <p:sp>
-        <p:nvSpPr>
-          <p:cNvPr id="47" name="Shape 44"/>
-          <p:cNvSpPr/>
-          <p:nvPr/>
-        </p:nvSpPr>
-        <p:spPr>
-          <a:xfrm>
-            <a:off x="4686300" y="2798064"/>
-            <a:ext cx="4183380" cy="1188720"/>
-          </a:xfrm>
-          <a:prstGeom prst="roundRect">
-            <a:avLst>
-              <a:gd name="adj" fmla="val 4615"/>
-            </a:avLst>
-          </a:prstGeom>
-          <a:solidFill>
-            <a:srgbClr val="112240"/>
-          </a:solidFill>
-          <a:ln w="12700">
-            <a:solidFill>
-              <a:srgbClr val="1A2B4A"/>
-            </a:solidFill>
-            <a:prstDash val="solid"/>
-          </a:ln>
-        </p:spPr>
-      </p:sp>
-      <p:sp>
-        <p:nvSpPr>
-          <p:cNvPr id="48" name="Text 45"/>
-          <p:cNvSpPr/>
-          <p:nvPr/>
-        </p:nvSpPr>
-        <p:spPr>
-          <a:xfrm>
-            <a:off x="4887468" y="2889504"/>
-            <a:ext cx="3781044" cy="219456"/>
-          </a:xfrm>
-          <a:prstGeom prst="rect">
-            <a:avLst/>
-          </a:prstGeom>
-          <a:noFill/>
-          <a:ln/>
-        </p:spPr>
-        <p:txBody>
-          <a:bodyPr wrap="square" lIns="0" tIns="0" rIns="0" bIns="0" rtlCol="0" anchor="ctr"/>
-          <a:lstStyle/>
-          <a:p>
-            <a:pPr indent="0" marL="0">
-              <a:buNone/>
-            </a:pPr>
-            <a:r>
-              <a:rPr lang="en-US" sz="1000" b="1" dirty="0">
-                <a:solidFill>
-                  <a:srgbClr val="00DFED"/>
-                </a:solidFill>
-                <a:latin typeface="Noto Sans" pitchFamily="34" charset="0"/>
-                <a:ea typeface="Noto Sans" pitchFamily="34" charset="-122"/>
-                <a:cs typeface="Noto Sans" pitchFamily="34" charset="-120"/>
-              </a:rPr>
-              <a:t>HITO EN CURSO — SEMANA 4 (SPRINT 2, 03–09 SEP)</a:t>
-            </a:r>
-            <a:endParaRPr lang="en-US" sz="1000" dirty="0"/>
-          </a:p>
-        </p:txBody>
-      </p:sp>
-      <p:sp>
-        <p:nvSpPr>
-          <p:cNvPr id="49" name="Text 46"/>
-          <p:cNvSpPr/>
-          <p:nvPr/>
-        </p:nvSpPr>
-        <p:spPr>
-          <a:xfrm>
-            <a:off x="4887468" y="3127248"/>
-            <a:ext cx="3781044" cy="768096"/>
-          </a:xfrm>
-          <a:prstGeom prst="rect">
-            <a:avLst/>
-          </a:prstGeom>
-          <a:noFill/>
-          <a:ln/>
-        </p:spPr>
-        <p:txBody>
-          <a:bodyPr wrap="square" lIns="0" tIns="0" rIns="0" bIns="0" rtlCol="0" anchor="ctr"/>
-          <a:lstStyle/>
-          <a:p>
-            <a:pPr indent="0" marL="0">
-              <a:lnSpc>
-                <a:spcPct val="100000"/>
-              </a:lnSpc>
-              <a:buNone/>
-            </a:pPr>
-            <a:r>
-              <a:rPr lang="en-US" sz="800" dirty="0">
-                <a:solidFill>
-                  <a:srgbClr val="D6D6D6"/>
-                </a:solidFill>
-                <a:latin typeface="Arial" pitchFamily="34" charset="0"/>
-                <a:ea typeface="Arial" pitchFamily="34" charset="-122"/>
-                <a:cs typeface="Arial" pitchFamily="34" charset="-120"/>
-              </a:rPr>
-              <a:t>Sprint 2 (skills 6–10): consolidar el feedback de la prueba EVT e incorporar las correcciones. Continuar bcv-clean-architecture, bcv-openapi-design, bcv-openfeign, bcv-azure-service-bus, bcv-spring-data-jpa-sql-server. Preparar el traspaso de Jose Luis (10 sep).</a:t>
-            </a:r>
-            <a:endParaRPr lang="en-US" sz="800" dirty="0"/>
-          </a:p>
-        </p:txBody>
-      </p:sp>
-      <p:sp>
-        <p:nvSpPr>
-          <p:cNvPr id="50" name="Shape 47"/>
-          <p:cNvSpPr/>
-          <p:nvPr/>
-        </p:nvSpPr>
-        <p:spPr>
-          <a:xfrm>
-            <a:off x="365760" y="4041648"/>
-            <a:ext cx="2023110" cy="731520"/>
-          </a:xfrm>
-          <a:prstGeom prst="roundRect">
-            <a:avLst>
-              <a:gd name="adj" fmla="val 7500"/>
-            </a:avLst>
-          </a:prstGeom>
-          <a:solidFill>
-            <a:srgbClr val="0A1A2E"/>
-          </a:solidFill>
-          <a:ln w="12700">
-            <a:solidFill>
-              <a:srgbClr val="1A2B4A"/>
-            </a:solidFill>
-            <a:prstDash val="solid"/>
-          </a:ln>
-        </p:spPr>
-      </p:sp>
-      <p:sp>
-        <p:nvSpPr>
-          <p:cNvPr id="51" name="Text 48"/>
-          <p:cNvSpPr/>
-          <p:nvPr/>
-        </p:nvSpPr>
-        <p:spPr>
-          <a:xfrm>
-            <a:off x="365760" y="4105656"/>
-            <a:ext cx="2023110" cy="292608"/>
-          </a:xfrm>
-          <a:prstGeom prst="rect">
-            <a:avLst/>
-          </a:prstGeom>
-          <a:noFill/>
-          <a:ln/>
-        </p:spPr>
-        <p:txBody>
-          <a:bodyPr wrap="square" lIns="0" tIns="0" rIns="0" bIns="0" rtlCol="0" anchor="ctr"/>
-          <a:lstStyle/>
-          <a:p>
-            <a:pPr algn="ctr" indent="0" marL="0">
-              <a:buNone/>
-            </a:pPr>
-            <a:r>
-              <a:rPr lang="en-US" sz="1800" b="1" dirty="0">
-                <a:solidFill>
-                  <a:srgbClr val="00DFED"/>
-                </a:solidFill>
-                <a:latin typeface="Noto Sans" pitchFamily="34" charset="0"/>
-                <a:ea typeface="Noto Sans" pitchFamily="34" charset="-122"/>
-                <a:cs typeface="Noto Sans" pitchFamily="34" charset="-120"/>
-              </a:rPr>
-              <a:t>2 h vs 8 h</a:t>
-            </a:r>
-            <a:endParaRPr lang="en-US" sz="1800" dirty="0"/>
-          </a:p>
-        </p:txBody>
-      </p:sp>
-      <p:sp>
-        <p:nvSpPr>
-          <p:cNvPr id="52" name="Text 49"/>
-          <p:cNvSpPr/>
-          <p:nvPr/>
-        </p:nvSpPr>
-        <p:spPr>
-          <a:xfrm>
-            <a:off x="457200" y="4407408"/>
-            <a:ext cx="1840230" cy="329184"/>
-          </a:xfrm>
-          <a:prstGeom prst="rect">
-            <a:avLst/>
-          </a:prstGeom>
-          <a:noFill/>
-          <a:ln/>
-        </p:spPr>
-        <p:txBody>
-          <a:bodyPr wrap="square" lIns="0" tIns="0" rIns="0" bIns="0" rtlCol="0" anchor="ctr"/>
-          <a:lstStyle/>
-          <a:p>
-            <a:pPr algn="ctr" indent="0" marL="0">
-              <a:lnSpc>
-                <a:spcPct val="100000"/>
-              </a:lnSpc>
-              <a:buNone/>
-            </a:pPr>
-            <a:r>
-              <a:rPr lang="en-US" sz="800" dirty="0">
-                <a:solidFill>
-                  <a:srgbClr val="D6D6D6"/>
-                </a:solidFill>
-                <a:latin typeface="Arial" pitchFamily="34" charset="0"/>
-                <a:ea typeface="Arial" pitchFamily="34" charset="-122"/>
-                <a:cs typeface="Arial" pitchFamily="34" charset="-120"/>
-              </a:rPr>
-              <a:t>F. Camargo (equipo dev banco) vs. forma tradicional (semana 2)</a:t>
-            </a:r>
-            <a:endParaRPr lang="en-US" sz="800" dirty="0"/>
-          </a:p>
-        </p:txBody>
-      </p:sp>
-      <p:sp>
-        <p:nvSpPr>
-          <p:cNvPr id="53" name="Shape 50"/>
-          <p:cNvSpPr/>
-          <p:nvPr/>
-        </p:nvSpPr>
-        <p:spPr>
-          <a:xfrm>
-            <a:off x="2526030" y="4041648"/>
-            <a:ext cx="2023110" cy="731520"/>
-          </a:xfrm>
-          <a:prstGeom prst="roundRect">
-            <a:avLst>
-              <a:gd name="adj" fmla="val 7500"/>
-            </a:avLst>
-          </a:prstGeom>
-          <a:solidFill>
-            <a:srgbClr val="0A1A2E"/>
-          </a:solidFill>
-          <a:ln w="12700">
-            <a:solidFill>
-              <a:srgbClr val="1A2B4A"/>
-            </a:solidFill>
-            <a:prstDash val="solid"/>
-          </a:ln>
-        </p:spPr>
-      </p:sp>
-      <p:sp>
-        <p:nvSpPr>
-          <p:cNvPr id="54" name="Text 51"/>
-          <p:cNvSpPr/>
-          <p:nvPr/>
-        </p:nvSpPr>
-        <p:spPr>
-          <a:xfrm>
-            <a:off x="2526030" y="4105656"/>
-            <a:ext cx="2023110" cy="292608"/>
-          </a:xfrm>
-          <a:prstGeom prst="rect">
-            <a:avLst/>
-          </a:prstGeom>
-          <a:noFill/>
-          <a:ln/>
-        </p:spPr>
-        <p:txBody>
-          <a:bodyPr wrap="square" lIns="0" tIns="0" rIns="0" bIns="0" rtlCol="0" anchor="ctr"/>
-          <a:lstStyle/>
-          <a:p>
-            <a:pPr algn="ctr" indent="0" marL="0">
-              <a:buNone/>
-            </a:pPr>
-            <a:r>
-              <a:rPr lang="en-US" sz="1800" b="1" dirty="0">
-                <a:solidFill>
-                  <a:srgbClr val="00DFED"/>
-                </a:solidFill>
-                <a:latin typeface="Noto Sans" pitchFamily="34" charset="0"/>
-                <a:ea typeface="Noto Sans" pitchFamily="34" charset="-122"/>
-                <a:cs typeface="Noto Sans" pitchFamily="34" charset="-120"/>
-              </a:rPr>
-              <a:t>~4 días</a:t>
-            </a:r>
-            <a:endParaRPr lang="en-US" sz="1800" dirty="0"/>
-          </a:p>
-        </p:txBody>
-      </p:sp>
-      <p:sp>
-        <p:nvSpPr>
-          <p:cNvPr id="55" name="Text 52"/>
-          <p:cNvSpPr/>
-          <p:nvPr/>
-        </p:nvSpPr>
-        <p:spPr>
-          <a:xfrm>
-            <a:off x="2617470" y="4407408"/>
-            <a:ext cx="1840230" cy="329184"/>
-          </a:xfrm>
-          <a:prstGeom prst="rect">
-            <a:avLst/>
-          </a:prstGeom>
-          <a:noFill/>
-          <a:ln/>
-        </p:spPr>
-        <p:txBody>
-          <a:bodyPr wrap="square" lIns="0" tIns="0" rIns="0" bIns="0" rtlCol="0" anchor="ctr"/>
-          <a:lstStyle/>
-          <a:p>
-            <a:pPr algn="ctr" indent="0" marL="0">
-              <a:lnSpc>
-                <a:spcPct val="100000"/>
-              </a:lnSpc>
-              <a:buNone/>
-            </a:pPr>
-            <a:r>
-              <a:rPr lang="en-US" sz="800" dirty="0">
-                <a:solidFill>
-                  <a:srgbClr val="D6D6D6"/>
-                </a:solidFill>
-                <a:latin typeface="Arial" pitchFamily="34" charset="0"/>
-                <a:ea typeface="Arial" pitchFamily="34" charset="-122"/>
-                <a:cs typeface="Arial" pitchFamily="34" charset="-120"/>
-              </a:rPr>
-              <a:t>ahorro medido en el EVT (semana 3)</a:t>
-            </a:r>
-            <a:endParaRPr lang="en-US" sz="800" dirty="0"/>
-          </a:p>
-        </p:txBody>
-      </p:sp>
-      <p:sp>
-        <p:nvSpPr>
-          <p:cNvPr id="56" name="Shape 53"/>
-          <p:cNvSpPr/>
-          <p:nvPr/>
-        </p:nvSpPr>
-        <p:spPr>
-          <a:xfrm>
-            <a:off x="4686300" y="4041648"/>
-            <a:ext cx="2023110" cy="731520"/>
-          </a:xfrm>
-          <a:prstGeom prst="roundRect">
-            <a:avLst>
-              <a:gd name="adj" fmla="val 7500"/>
-            </a:avLst>
-          </a:prstGeom>
-          <a:solidFill>
-            <a:srgbClr val="0A1A2E"/>
-          </a:solidFill>
-          <a:ln w="12700">
-            <a:solidFill>
-              <a:srgbClr val="1A2B4A"/>
-            </a:solidFill>
-            <a:prstDash val="solid"/>
-          </a:ln>
-        </p:spPr>
-      </p:sp>
-      <p:sp>
-        <p:nvSpPr>
-          <p:cNvPr id="57" name="Text 54"/>
-          <p:cNvSpPr/>
-          <p:nvPr/>
-        </p:nvSpPr>
-        <p:spPr>
-          <a:xfrm>
-            <a:off x="4686300" y="4105656"/>
-            <a:ext cx="2023110" cy="292608"/>
-          </a:xfrm>
-          <a:prstGeom prst="rect">
-            <a:avLst/>
-          </a:prstGeom>
-          <a:noFill/>
-          <a:ln/>
-        </p:spPr>
-        <p:txBody>
-          <a:bodyPr wrap="square" lIns="0" tIns="0" rIns="0" bIns="0" rtlCol="0" anchor="ctr"/>
-          <a:lstStyle/>
-          <a:p>
-            <a:pPr algn="ctr" indent="0" marL="0">
-              <a:buNone/>
-            </a:pPr>
-            <a:r>
-              <a:rPr lang="en-US" sz="1800" b="1" dirty="0">
-                <a:solidFill>
-                  <a:srgbClr val="00DFED"/>
-                </a:solidFill>
-                <a:latin typeface="Noto Sans" pitchFamily="34" charset="0"/>
-                <a:ea typeface="Noto Sans" pitchFamily="34" charset="-122"/>
-                <a:cs typeface="Noto Sans" pitchFamily="34" charset="-120"/>
-              </a:rPr>
-              <a:t>3 / 8</a:t>
-            </a:r>
-            <a:endParaRPr lang="en-US" sz="1800" dirty="0"/>
-          </a:p>
-        </p:txBody>
-      </p:sp>
-      <p:sp>
-        <p:nvSpPr>
-          <p:cNvPr id="58" name="Text 55"/>
-          <p:cNvSpPr/>
-          <p:nvPr/>
-        </p:nvSpPr>
-        <p:spPr>
-          <a:xfrm>
-            <a:off x="4777740" y="4407408"/>
-            <a:ext cx="1840230" cy="329184"/>
-          </a:xfrm>
-          <a:prstGeom prst="rect">
-            <a:avLst/>
-          </a:prstGeom>
-          <a:noFill/>
-          <a:ln/>
-        </p:spPr>
-        <p:txBody>
-          <a:bodyPr wrap="square" lIns="0" tIns="0" rIns="0" bIns="0" rtlCol="0" anchor="ctr"/>
-          <a:lstStyle/>
-          <a:p>
-            <a:pPr algn="ctr" indent="0" marL="0">
-              <a:lnSpc>
-                <a:spcPct val="100000"/>
-              </a:lnSpc>
-              <a:buNone/>
-            </a:pPr>
-            <a:r>
-              <a:rPr lang="en-US" sz="800" dirty="0">
-                <a:solidFill>
-                  <a:srgbClr val="D6D6D6"/>
-                </a:solidFill>
-                <a:latin typeface="Arial" pitchFamily="34" charset="0"/>
-                <a:ea typeface="Arial" pitchFamily="34" charset="-122"/>
-                <a:cs typeface="Arial" pitchFamily="34" charset="-120"/>
-              </a:rPr>
-              <a:t>semanas completadas</a:t>
-            </a:r>
-            <a:endParaRPr lang="en-US" sz="800" dirty="0"/>
-          </a:p>
-        </p:txBody>
-      </p:sp>
-      <p:sp>
-        <p:nvSpPr>
-          <p:cNvPr id="59" name="Shape 56"/>
-          <p:cNvSpPr/>
-          <p:nvPr/>
-        </p:nvSpPr>
-        <p:spPr>
-          <a:xfrm>
-            <a:off x="6846570" y="4041648"/>
-            <a:ext cx="2023110" cy="731520"/>
-          </a:xfrm>
-          <a:prstGeom prst="roundRect">
-            <a:avLst>
-              <a:gd name="adj" fmla="val 7500"/>
-            </a:avLst>
-          </a:prstGeom>
-          <a:solidFill>
-            <a:srgbClr val="0A1A2E"/>
-          </a:solidFill>
-          <a:ln w="12700">
-            <a:solidFill>
-              <a:srgbClr val="1A2B4A"/>
-            </a:solidFill>
-            <a:prstDash val="solid"/>
-          </a:ln>
-        </p:spPr>
-      </p:sp>
-      <p:sp>
-        <p:nvSpPr>
-          <p:cNvPr id="60" name="Text 57"/>
-          <p:cNvSpPr/>
-          <p:nvPr/>
-        </p:nvSpPr>
-        <p:spPr>
-          <a:xfrm>
-            <a:off x="6846570" y="4105656"/>
-            <a:ext cx="2023110" cy="292608"/>
-          </a:xfrm>
-          <a:prstGeom prst="rect">
-            <a:avLst/>
-          </a:prstGeom>
-          <a:noFill/>
-          <a:ln/>
-        </p:spPr>
-        <p:txBody>
-          <a:bodyPr wrap="square" lIns="0" tIns="0" rIns="0" bIns="0" rtlCol="0" anchor="ctr"/>
-          <a:lstStyle/>
-          <a:p>
-            <a:pPr algn="ctr" indent="0" marL="0">
-              <a:buNone/>
-            </a:pPr>
-            <a:r>
-              <a:rPr lang="en-US" sz="1800" b="1" dirty="0">
-                <a:solidFill>
-                  <a:srgbClr val="00DFED"/>
-                </a:solidFill>
-                <a:latin typeface="Noto Sans" pitchFamily="34" charset="0"/>
-                <a:ea typeface="Noto Sans" pitchFamily="34" charset="-122"/>
-                <a:cs typeface="Noto Sans" pitchFamily="34" charset="-120"/>
-              </a:rPr>
-              <a:t>09 oct</a:t>
-            </a:r>
-            <a:endParaRPr lang="en-US" sz="1800" dirty="0"/>
-          </a:p>
-        </p:txBody>
-      </p:sp>
-      <p:sp>
-        <p:nvSpPr>
-          <p:cNvPr id="61" name="Text 58"/>
-          <p:cNvSpPr/>
-          <p:nvPr/>
-        </p:nvSpPr>
-        <p:spPr>
-          <a:xfrm>
-            <a:off x="6938010" y="4407408"/>
-            <a:ext cx="1840230" cy="329184"/>
-          </a:xfrm>
-          <a:prstGeom prst="rect">
-            <a:avLst/>
-          </a:prstGeom>
-          <a:noFill/>
-          <a:ln/>
-        </p:spPr>
-        <p:txBody>
-          <a:bodyPr wrap="square" lIns="0" tIns="0" rIns="0" bIns="0" rtlCol="0" anchor="ctr"/>
-          <a:lstStyle/>
-          <a:p>
-            <a:pPr algn="ctr" indent="0" marL="0">
-              <a:lnSpc>
-                <a:spcPct val="100000"/>
-              </a:lnSpc>
-              <a:buNone/>
-            </a:pPr>
-            <a:r>
-              <a:rPr lang="en-US" sz="800" dirty="0">
-                <a:solidFill>
-                  <a:srgbClr val="D6D6D6"/>
-                </a:solidFill>
-                <a:latin typeface="Arial" pitchFamily="34" charset="0"/>
-                <a:ea typeface="Arial" pitchFamily="34" charset="-122"/>
-                <a:cs typeface="Arial" pitchFamily="34" charset="-120"/>
-              </a:rPr>
-              <a:t>cierre y traspaso de entregables</a:t>
-            </a:r>
-            <a:endParaRPr lang="en-US" sz="800" dirty="0"/>
-          </a:p>
-        </p:txBody>
-      </p:sp>
       <p:pic>
         <p:nvPicPr>
-          <p:cNvPr id="62" name="Image 1" descr="preencoded.png">    </p:cNvPr>
+          <p:cNvPr id="80" name="Image 1" descr="preencoded.png">    </p:cNvPr>
           <p:cNvPicPr>
             <a:picLocks noChangeAspect="1"/>
           </p:cNvPicPr>
@@ -24622,7 +25054,7 @@
       </p:pic>
       <p:sp>
         <p:nvSpPr>
-          <p:cNvPr id="63" name="Text 59"/>
+          <p:cNvPr id="81" name="Text 77"/>
           <p:cNvSpPr/>
           <p:nvPr/>
         </p:nvSpPr>
@@ -24661,7 +25093,7 @@
       </p:sp>
       <p:sp>
         <p:nvSpPr>
-          <p:cNvPr id="64" name="Text 60"/>
+          <p:cNvPr id="82" name="Text 78"/>
           <p:cNvSpPr/>
           <p:nvPr/>
         </p:nvSpPr>

</xml_diff>